<commit_message>
Add painted ROI gallery slide with 5 region screenshots
ユーザー提供の塗ったROIスクショ5枚を解剖順(M1_hand→Internal_capsule→
Cerebral_peduncle→Pons→Medulla)でギャラリースライドとして追加。全12枚に。

https://claude.ai/code/session_015fXNKSPxUFurYN4t1GMdvb
</commit_message>
<xml_diff>
--- a/slides/CST_tractography_slides.pptx
+++ b/slides/CST_tractography_slides.pptx
@@ -16,6 +16,7 @@
     <p:sldId id="264" r:id="rId15"/>
     <p:sldId id="265" r:id="rId16"/>
     <p:sldId id="266" r:id="rId17"/>
+    <p:sldId id="267" r:id="rId18"/>
   </p:sldIdLst>
   <p:sldSz cx="12191695" cy="6858000" type="screen4x3"/>
   <p:notesSz cx="6858000" cy="9144000"/>
@@ -3643,7 +3644,7 @@
                 <a:latin typeface="Yu Gothic"/>
                 <a:ea typeface="Yu Gothic"/>
               </a:rPr>
-              <a:t>STEP 6 ②</a:t>
+              <a:t>STEP 6 ①</a:t>
             </a:r>
           </a:p>
         </p:txBody>
@@ -3679,7 +3680,7 @@
                 <a:latin typeface="Yu Gothic"/>
                 <a:ea typeface="Yu Gothic"/>
               </a:rPr>
-              <a:t>可視化：CST のみ</a:t>
+              <a:t>可視化：全ての神経</a:t>
             </a:r>
           </a:p>
         </p:txBody>
@@ -3758,7 +3759,7 @@
                 <a:latin typeface="Yu Gothic"/>
                 <a:ea typeface="Yu Gothic"/>
               </a:rPr>
-              <a:t>●  選んだ領域だけを通る神経を表示</a:t>
+              <a:t>●  Tractography を選択</a:t>
             </a:r>
           </a:p>
           <a:p>
@@ -3778,7 +3779,7 @@
                 <a:latin typeface="Yu Gothic"/>
                 <a:ea typeface="Yu Gothic"/>
               </a:rPr>
-              <a:t>     ROI を全て通過するトラクトのみにチェック</a:t>
+              <a:t>     mrview の Tool → Tractography を開く</a:t>
             </a:r>
           </a:p>
           <a:p>
@@ -3798,7 +3799,7 @@
                 <a:latin typeface="Yu Gothic"/>
                 <a:ea typeface="Yu Gothic"/>
               </a:rPr>
-              <a:t>●  結果</a:t>
+              <a:t>●  Run で得た2ファイルを読み込む</a:t>
             </a:r>
           </a:p>
           <a:p>
@@ -3818,7 +3819,7 @@
                 <a:latin typeface="Yu Gothic"/>
                 <a:ea typeface="Yu Gothic"/>
               </a:rPr>
-              <a:t>     選んだ通過域を通る神経 ＝ CST だけが表示される</a:t>
+              <a:t>     生成したトラクトを表示</a:t>
             </a:r>
           </a:p>
           <a:p>
@@ -3838,7 +3839,7 @@
                 <a:latin typeface="Yu Gothic"/>
                 <a:ea typeface="Yu Gothic"/>
               </a:rPr>
-              <a:t>●  確認ポイント</a:t>
+              <a:t>●  結果</a:t>
             </a:r>
           </a:p>
           <a:p>
@@ -3858,7 +3859,7 @@
                 <a:latin typeface="Yu Gothic"/>
                 <a:ea typeface="Yu Gothic"/>
               </a:rPr>
-              <a:t>     M1 から延髄まで連続して走行しているか</a:t>
+              <a:t>     脳全体の神経線維（全トラクト）が見える図</a:t>
             </a:r>
           </a:p>
         </p:txBody>
@@ -3898,7 +3899,7 @@
                 <a:latin typeface="Yu Gothic"/>
                 <a:ea typeface="Yu Gothic"/>
               </a:rPr>
-              <a:t>📝 tracks_CST.tck を読み込むと CST のみが描出される。</a:t>
+              <a:t>📝 まずは絞り込み前の全神経を確認する。</a:t>
             </a:r>
           </a:p>
         </p:txBody>
@@ -3999,7 +4000,7 @@
                 <a:latin typeface="Yu Gothic"/>
                 <a:ea typeface="Yu Gothic"/>
               </a:rPr>
-              <a:t>CST のみ表示のスクショ</a:t>
+              <a:t>全トラクト表示のスクショ</a:t>
             </a:r>
           </a:p>
         </p:txBody>
@@ -4037,6 +4038,594 @@
             <a:avLst/>
           </a:prstGeom>
           <a:solidFill>
+            <a:srgbClr val="FFFFFF"/>
+          </a:solidFill>
+          <a:ln>
+            <a:noFill/>
+          </a:ln>
+          <a:effectLst/>
+        </p:spPr>
+        <p:style>
+          <a:lnRef idx="1">
+            <a:schemeClr val="accent1"/>
+          </a:lnRef>
+          <a:fillRef idx="3">
+            <a:schemeClr val="accent1"/>
+          </a:fillRef>
+          <a:effectRef idx="2">
+            <a:schemeClr val="accent1"/>
+          </a:effectRef>
+          <a:fontRef idx="minor">
+            <a:schemeClr val="lt1"/>
+          </a:fontRef>
+        </p:style>
+        <p:txBody>
+          <a:bodyPr rtlCol="0" anchor="ctr"/>
+          <a:lstStyle/>
+          <a:p>
+            <a:pPr algn="ctr"/>
+          </a:p>
+        </p:txBody>
+      </p:sp>
+      <p:sp>
+        <p:nvSpPr>
+          <p:cNvPr id="3" name="Rectangle 2"/>
+          <p:cNvSpPr/>
+          <p:nvPr/>
+        </p:nvSpPr>
+        <p:spPr>
+          <a:xfrm>
+            <a:off x="0" y="0"/>
+            <a:ext cx="12191695" cy="1051560"/>
+          </a:xfrm>
+          <a:prstGeom prst="rect">
+            <a:avLst/>
+          </a:prstGeom>
+          <a:solidFill>
+            <a:srgbClr val="162A47"/>
+          </a:solidFill>
+          <a:ln>
+            <a:noFill/>
+          </a:ln>
+          <a:effectLst/>
+        </p:spPr>
+        <p:style>
+          <a:lnRef idx="1">
+            <a:schemeClr val="accent1"/>
+          </a:lnRef>
+          <a:fillRef idx="3">
+            <a:schemeClr val="accent1"/>
+          </a:fillRef>
+          <a:effectRef idx="2">
+            <a:schemeClr val="accent1"/>
+          </a:effectRef>
+          <a:fontRef idx="minor">
+            <a:schemeClr val="lt1"/>
+          </a:fontRef>
+        </p:style>
+        <p:txBody>
+          <a:bodyPr rtlCol="0" anchor="ctr"/>
+          <a:lstStyle/>
+          <a:p>
+            <a:pPr algn="ctr"/>
+          </a:p>
+        </p:txBody>
+      </p:sp>
+      <p:sp>
+        <p:nvSpPr>
+          <p:cNvPr id="4" name="Rectangle 3"/>
+          <p:cNvSpPr/>
+          <p:nvPr/>
+        </p:nvSpPr>
+        <p:spPr>
+          <a:xfrm>
+            <a:off x="0" y="0"/>
+            <a:ext cx="164592" cy="6858000"/>
+          </a:xfrm>
+          <a:prstGeom prst="rect">
+            <a:avLst/>
+          </a:prstGeom>
+          <a:solidFill>
+            <a:srgbClr val="35C7EC"/>
+          </a:solidFill>
+          <a:ln>
+            <a:noFill/>
+          </a:ln>
+          <a:effectLst/>
+        </p:spPr>
+        <p:style>
+          <a:lnRef idx="1">
+            <a:schemeClr val="accent1"/>
+          </a:lnRef>
+          <a:fillRef idx="3">
+            <a:schemeClr val="accent1"/>
+          </a:fillRef>
+          <a:effectRef idx="2">
+            <a:schemeClr val="accent1"/>
+          </a:effectRef>
+          <a:fontRef idx="minor">
+            <a:schemeClr val="lt1"/>
+          </a:fontRef>
+        </p:style>
+        <p:txBody>
+          <a:bodyPr rtlCol="0" anchor="ctr"/>
+          <a:lstStyle/>
+          <a:p>
+            <a:pPr algn="ctr"/>
+          </a:p>
+        </p:txBody>
+      </p:sp>
+      <p:sp>
+        <p:nvSpPr>
+          <p:cNvPr id="5" name="Rounded Rectangle 4"/>
+          <p:cNvSpPr/>
+          <p:nvPr/>
+        </p:nvSpPr>
+        <p:spPr>
+          <a:xfrm>
+            <a:off x="502920" y="274320"/>
+            <a:ext cx="1828800" cy="502920"/>
+          </a:xfrm>
+          <a:prstGeom prst="roundRect">
+            <a:avLst>
+              <a:gd name="adj" fmla="val 50000"/>
+            </a:avLst>
+          </a:prstGeom>
+          <a:solidFill>
+            <a:srgbClr val="35C7EC"/>
+          </a:solidFill>
+          <a:ln>
+            <a:noFill/>
+          </a:ln>
+          <a:effectLst/>
+        </p:spPr>
+        <p:style>
+          <a:lnRef idx="1">
+            <a:schemeClr val="accent1"/>
+          </a:lnRef>
+          <a:fillRef idx="3">
+            <a:schemeClr val="accent1"/>
+          </a:fillRef>
+          <a:effectRef idx="2">
+            <a:schemeClr val="accent1"/>
+          </a:effectRef>
+          <a:fontRef idx="minor">
+            <a:schemeClr val="lt1"/>
+          </a:fontRef>
+        </p:style>
+        <p:txBody>
+          <a:bodyPr rtlCol="0" anchor="ctr"/>
+          <a:lstStyle/>
+          <a:p>
+            <a:pPr algn="ctr"/>
+          </a:p>
+        </p:txBody>
+      </p:sp>
+      <p:sp>
+        <p:nvSpPr>
+          <p:cNvPr id="6" name="TextBox 5"/>
+          <p:cNvSpPr txBox="1"/>
+          <p:nvPr/>
+        </p:nvSpPr>
+        <p:spPr>
+          <a:xfrm>
+            <a:off x="502920" y="274320"/>
+            <a:ext cx="1828800" cy="502920"/>
+          </a:xfrm>
+          <a:prstGeom prst="rect">
+            <a:avLst/>
+          </a:prstGeom>
+          <a:noFill/>
+        </p:spPr>
+        <p:txBody>
+          <a:bodyPr wrap="square" anchor="ctr" lIns="25400" rIns="25400" tIns="25400" bIns="25400">
+            <a:spAutoFit/>
+          </a:bodyPr>
+          <a:lstStyle/>
+          <a:p>
+            <a:pPr algn="ctr"/>
+            <a:r>
+              <a:rPr sz="1600" b="1">
+                <a:solidFill>
+                  <a:srgbClr val="162A47"/>
+                </a:solidFill>
+                <a:latin typeface="Yu Gothic"/>
+                <a:ea typeface="Yu Gothic"/>
+              </a:rPr>
+              <a:t>STEP 6 ②</a:t>
+            </a:r>
+          </a:p>
+        </p:txBody>
+      </p:sp>
+      <p:sp>
+        <p:nvSpPr>
+          <p:cNvPr id="7" name="TextBox 6"/>
+          <p:cNvSpPr txBox="1"/>
+          <p:nvPr/>
+        </p:nvSpPr>
+        <p:spPr>
+          <a:xfrm>
+            <a:off x="2514600" y="0"/>
+            <a:ext cx="9219895" cy="1051560"/>
+          </a:xfrm>
+          <a:prstGeom prst="rect">
+            <a:avLst/>
+          </a:prstGeom>
+          <a:noFill/>
+        </p:spPr>
+        <p:txBody>
+          <a:bodyPr wrap="square" anchor="ctr" lIns="25400" rIns="25400" tIns="25400" bIns="25400">
+            <a:spAutoFit/>
+          </a:bodyPr>
+          <a:lstStyle/>
+          <a:p>
+            <a:pPr algn="l"/>
+            <a:r>
+              <a:rPr sz="2800" b="1">
+                <a:solidFill>
+                  <a:srgbClr val="FFFFFF"/>
+                </a:solidFill>
+                <a:latin typeface="Yu Gothic"/>
+                <a:ea typeface="Yu Gothic"/>
+              </a:rPr>
+              <a:t>可視化：CST のみ</a:t>
+            </a:r>
+          </a:p>
+        </p:txBody>
+      </p:sp>
+      <p:sp>
+        <p:nvSpPr>
+          <p:cNvPr id="8" name="TextBox 7"/>
+          <p:cNvSpPr txBox="1"/>
+          <p:nvPr/>
+        </p:nvSpPr>
+        <p:spPr>
+          <a:xfrm>
+            <a:off x="11094415" y="292608"/>
+            <a:ext cx="822960" cy="457200"/>
+          </a:xfrm>
+          <a:prstGeom prst="rect">
+            <a:avLst/>
+          </a:prstGeom>
+          <a:noFill/>
+        </p:spPr>
+        <p:txBody>
+          <a:bodyPr wrap="square" anchor="ctr" lIns="25400" rIns="25400" tIns="25400" bIns="25400">
+            <a:spAutoFit/>
+          </a:bodyPr>
+          <a:lstStyle/>
+          <a:p>
+            <a:pPr algn="r"/>
+            <a:r>
+              <a:rPr sz="1200">
+                <a:solidFill>
+                  <a:srgbClr val="AFC6DB"/>
+                </a:solidFill>
+                <a:latin typeface="Yu Gothic"/>
+                <a:ea typeface="Yu Gothic"/>
+              </a:rPr>
+              <a:t>11</a:t>
+            </a:r>
+          </a:p>
+        </p:txBody>
+      </p:sp>
+      <p:sp>
+        <p:nvSpPr>
+          <p:cNvPr id="9" name="TextBox 8"/>
+          <p:cNvSpPr txBox="1"/>
+          <p:nvPr/>
+        </p:nvSpPr>
+        <p:spPr>
+          <a:xfrm>
+            <a:off x="640080" y="1325880"/>
+            <a:ext cx="5212080" cy="3291840"/>
+          </a:xfrm>
+          <a:prstGeom prst="rect">
+            <a:avLst/>
+          </a:prstGeom>
+          <a:noFill/>
+        </p:spPr>
+        <p:txBody>
+          <a:bodyPr wrap="square" anchor="t" lIns="25400" rIns="25400" tIns="25400" bIns="25400">
+            <a:spAutoFit/>
+          </a:bodyPr>
+          <a:lstStyle/>
+          <a:p>
+            <a:pPr algn="l">
+              <a:lnSpc>
+                <a:spcPct val="115000"/>
+              </a:lnSpc>
+              <a:spcAft>
+                <a:spcPts val="200"/>
+              </a:spcAft>
+            </a:pPr>
+            <a:r>
+              <a:rPr sz="1600" b="1">
+                <a:solidFill>
+                  <a:srgbClr val="1F6FB2"/>
+                </a:solidFill>
+                <a:latin typeface="Yu Gothic"/>
+                <a:ea typeface="Yu Gothic"/>
+              </a:rPr>
+              <a:t>●  選んだ領域だけを通る神経を表示</a:t>
+            </a:r>
+          </a:p>
+          <a:p>
+            <a:pPr algn="l">
+              <a:lnSpc>
+                <a:spcPct val="120000"/>
+              </a:lnSpc>
+              <a:spcAft>
+                <a:spcPts val="1200"/>
+              </a:spcAft>
+            </a:pPr>
+            <a:r>
+              <a:rPr sz="1400">
+                <a:solidFill>
+                  <a:srgbClr val="1B242E"/>
+                </a:solidFill>
+                <a:latin typeface="Yu Gothic"/>
+                <a:ea typeface="Yu Gothic"/>
+              </a:rPr>
+              <a:t>     ROI を全て通過するトラクトのみにチェック</a:t>
+            </a:r>
+          </a:p>
+          <a:p>
+            <a:pPr algn="l">
+              <a:lnSpc>
+                <a:spcPct val="115000"/>
+              </a:lnSpc>
+              <a:spcAft>
+                <a:spcPts val="200"/>
+              </a:spcAft>
+            </a:pPr>
+            <a:r>
+              <a:rPr sz="1600" b="1">
+                <a:solidFill>
+                  <a:srgbClr val="1F6FB2"/>
+                </a:solidFill>
+                <a:latin typeface="Yu Gothic"/>
+                <a:ea typeface="Yu Gothic"/>
+              </a:rPr>
+              <a:t>●  結果</a:t>
+            </a:r>
+          </a:p>
+          <a:p>
+            <a:pPr algn="l">
+              <a:lnSpc>
+                <a:spcPct val="120000"/>
+              </a:lnSpc>
+              <a:spcAft>
+                <a:spcPts val="1200"/>
+              </a:spcAft>
+            </a:pPr>
+            <a:r>
+              <a:rPr sz="1400">
+                <a:solidFill>
+                  <a:srgbClr val="1B242E"/>
+                </a:solidFill>
+                <a:latin typeface="Yu Gothic"/>
+                <a:ea typeface="Yu Gothic"/>
+              </a:rPr>
+              <a:t>     選んだ通過域を通る神経 ＝ CST だけが表示される</a:t>
+            </a:r>
+          </a:p>
+          <a:p>
+            <a:pPr algn="l">
+              <a:lnSpc>
+                <a:spcPct val="115000"/>
+              </a:lnSpc>
+              <a:spcAft>
+                <a:spcPts val="200"/>
+              </a:spcAft>
+            </a:pPr>
+            <a:r>
+              <a:rPr sz="1600" b="1">
+                <a:solidFill>
+                  <a:srgbClr val="1F6FB2"/>
+                </a:solidFill>
+                <a:latin typeface="Yu Gothic"/>
+                <a:ea typeface="Yu Gothic"/>
+              </a:rPr>
+              <a:t>●  確認ポイント</a:t>
+            </a:r>
+          </a:p>
+          <a:p>
+            <a:pPr algn="l">
+              <a:lnSpc>
+                <a:spcPct val="120000"/>
+              </a:lnSpc>
+              <a:spcAft>
+                <a:spcPts val="1200"/>
+              </a:spcAft>
+            </a:pPr>
+            <a:r>
+              <a:rPr sz="1400">
+                <a:solidFill>
+                  <a:srgbClr val="1B242E"/>
+                </a:solidFill>
+                <a:latin typeface="Yu Gothic"/>
+                <a:ea typeface="Yu Gothic"/>
+              </a:rPr>
+              <a:t>     M1 から延髄まで連続して走行しているか</a:t>
+            </a:r>
+          </a:p>
+        </p:txBody>
+      </p:sp>
+      <p:sp>
+        <p:nvSpPr>
+          <p:cNvPr id="10" name="TextBox 9"/>
+          <p:cNvSpPr txBox="1"/>
+          <p:nvPr/>
+        </p:nvSpPr>
+        <p:spPr>
+          <a:xfrm>
+            <a:off x="640080" y="5989320"/>
+            <a:ext cx="5212080" cy="640080"/>
+          </a:xfrm>
+          <a:prstGeom prst="rect">
+            <a:avLst/>
+          </a:prstGeom>
+          <a:noFill/>
+        </p:spPr>
+        <p:txBody>
+          <a:bodyPr wrap="square" anchor="t" lIns="25400" rIns="25400" tIns="25400" bIns="25400">
+            <a:spAutoFit/>
+          </a:bodyPr>
+          <a:lstStyle/>
+          <a:p>
+            <a:pPr algn="l">
+              <a:lnSpc>
+                <a:spcPct val="115000"/>
+              </a:lnSpc>
+            </a:pPr>
+            <a:r>
+              <a:rPr sz="1200" i="1">
+                <a:solidFill>
+                  <a:srgbClr val="5A6B7B"/>
+                </a:solidFill>
+                <a:latin typeface="Yu Gothic"/>
+                <a:ea typeface="Yu Gothic"/>
+              </a:rPr>
+              <a:t>📝 tracks_CST.tck を読み込むと CST のみが描出される。</a:t>
+            </a:r>
+          </a:p>
+        </p:txBody>
+      </p:sp>
+      <p:sp>
+        <p:nvSpPr>
+          <p:cNvPr id="11" name="Rounded Rectangle 10"/>
+          <p:cNvSpPr/>
+          <p:nvPr/>
+        </p:nvSpPr>
+        <p:spPr>
+          <a:xfrm>
+            <a:off x="6126480" y="1325880"/>
+            <a:ext cx="5440680" cy="4937760"/>
+          </a:xfrm>
+          <a:prstGeom prst="roundRect">
+            <a:avLst>
+              <a:gd name="adj" fmla="val 3000"/>
+            </a:avLst>
+          </a:prstGeom>
+          <a:solidFill>
+            <a:srgbClr val="E6ECF2"/>
+          </a:solidFill>
+          <a:ln w="15875">
+            <a:solidFill>
+              <a:srgbClr val="B4C2D0"/>
+            </a:solidFill>
+          </a:ln>
+          <a:effectLst/>
+        </p:spPr>
+        <p:style>
+          <a:lnRef idx="1">
+            <a:schemeClr val="accent1"/>
+          </a:lnRef>
+          <a:fillRef idx="3">
+            <a:schemeClr val="accent1"/>
+          </a:fillRef>
+          <a:effectRef idx="2">
+            <a:schemeClr val="accent1"/>
+          </a:effectRef>
+          <a:fontRef idx="minor">
+            <a:schemeClr val="lt1"/>
+          </a:fontRef>
+        </p:style>
+        <p:txBody>
+          <a:bodyPr rtlCol="0" anchor="ctr"/>
+          <a:lstStyle/>
+          <a:p>
+            <a:pPr algn="ctr"/>
+          </a:p>
+        </p:txBody>
+      </p:sp>
+      <p:sp>
+        <p:nvSpPr>
+          <p:cNvPr id="12" name="TextBox 11"/>
+          <p:cNvSpPr txBox="1"/>
+          <p:nvPr/>
+        </p:nvSpPr>
+        <p:spPr>
+          <a:xfrm>
+            <a:off x="6126480" y="1325880"/>
+            <a:ext cx="5440680" cy="4937760"/>
+          </a:xfrm>
+          <a:prstGeom prst="rect">
+            <a:avLst/>
+          </a:prstGeom>
+          <a:noFill/>
+        </p:spPr>
+        <p:txBody>
+          <a:bodyPr wrap="square" anchor="ctr" lIns="25400" rIns="25400" tIns="25400" bIns="25400">
+            <a:spAutoFit/>
+          </a:bodyPr>
+          <a:lstStyle/>
+          <a:p>
+            <a:pPr algn="ctr">
+              <a:spcAft>
+                <a:spcPts val="400"/>
+              </a:spcAft>
+            </a:pPr>
+            <a:r>
+              <a:rPr sz="3000">
+                <a:solidFill>
+                  <a:srgbClr val="B4C2D0"/>
+                </a:solidFill>
+                <a:latin typeface="Yu Gothic"/>
+                <a:ea typeface="Yu Gothic"/>
+              </a:rPr>
+              <a:t>🖼</a:t>
+            </a:r>
+          </a:p>
+          <a:p>
+            <a:pPr algn="ctr"/>
+            <a:r>
+              <a:rPr sz="1300" b="1">
+                <a:solidFill>
+                  <a:srgbClr val="5A6B7B"/>
+                </a:solidFill>
+                <a:latin typeface="Yu Gothic"/>
+                <a:ea typeface="Yu Gothic"/>
+              </a:rPr>
+              <a:t>CST のみ表示のスクショ</a:t>
+            </a:r>
+          </a:p>
+        </p:txBody>
+      </p:sp>
+    </p:spTree>
+  </p:cSld>
+  <p:clrMapOvr>
+    <a:masterClrMapping/>
+  </p:clrMapOvr>
+</p:sld>
+</file>
+
+<file path=ppt/slides/slide12.xml><?xml version="1.0" encoding="utf-8"?>
+<p:sld xmlns:a="http://schemas.openxmlformats.org/drawingml/2006/main" xmlns:p="http://schemas.openxmlformats.org/presentationml/2006/main" xmlns:r="http://schemas.openxmlformats.org/officeDocument/2006/relationships">
+  <p:cSld>
+    <p:spTree>
+      <p:nvGrpSpPr>
+        <p:cNvPr id="1" name=""/>
+        <p:cNvGrpSpPr/>
+        <p:nvPr/>
+      </p:nvGrpSpPr>
+      <p:grpSpPr/>
+      <p:sp>
+        <p:nvSpPr>
+          <p:cNvPr id="2" name="Rectangle 1"/>
+          <p:cNvSpPr/>
+          <p:nvPr/>
+        </p:nvSpPr>
+        <p:spPr>
+          <a:xfrm>
+            <a:off x="0" y="0"/>
+            <a:ext cx="12191695" cy="6858000"/>
+          </a:xfrm>
+          <a:prstGeom prst="rect">
+            <a:avLst/>
+          </a:prstGeom>
+          <a:solidFill>
             <a:srgbClr val="162A47"/>
           </a:solidFill>
           <a:ln>
@@ -9372,7 +9961,7 @@
                 <a:latin typeface="Yu Gothic"/>
                 <a:ea typeface="Yu Gothic"/>
               </a:rPr>
-              <a:t>ROI Editor / カンデル図のスクショ</a:t>
+              <a:t>ROI Editor 操作画面のスクショ</a:t>
             </a:r>
           </a:p>
         </p:txBody>
@@ -9410,7 +9999,7 @@
             <a:avLst/>
           </a:prstGeom>
           <a:solidFill>
-            <a:srgbClr val="FFFFFF"/>
+            <a:srgbClr val="0E1620"/>
           </a:solidFill>
           <a:ln>
             <a:noFill/>
@@ -9529,22 +10118,140 @@
       </p:sp>
       <p:sp>
         <p:nvSpPr>
-          <p:cNvPr id="5" name="Rounded Rectangle 4"/>
+          <p:cNvPr id="5" name="TextBox 4"/>
+          <p:cNvSpPr txBox="1"/>
+          <p:nvPr/>
+        </p:nvSpPr>
+        <p:spPr>
+          <a:xfrm>
+            <a:off x="502920" y="0"/>
+            <a:ext cx="10515600" cy="1051560"/>
+          </a:xfrm>
+          <a:prstGeom prst="rect">
+            <a:avLst/>
+          </a:prstGeom>
+          <a:noFill/>
+        </p:spPr>
+        <p:txBody>
+          <a:bodyPr wrap="square" anchor="ctr" lIns="25400" rIns="25400" tIns="25400" bIns="25400">
+            <a:spAutoFit/>
+          </a:bodyPr>
+          <a:lstStyle/>
+          <a:p>
+            <a:pPr algn="l"/>
+            <a:r>
+              <a:rPr sz="2800" b="1">
+                <a:solidFill>
+                  <a:srgbClr val="FFFFFF"/>
+                </a:solidFill>
+                <a:latin typeface="Yu Gothic"/>
+                <a:ea typeface="Yu Gothic"/>
+              </a:rPr>
+              <a:t>塗った領域：5つの ROI（CST の通過域）</a:t>
+            </a:r>
+          </a:p>
+        </p:txBody>
+      </p:sp>
+      <p:sp>
+        <p:nvSpPr>
+          <p:cNvPr id="6" name="TextBox 5"/>
+          <p:cNvSpPr txBox="1"/>
+          <p:nvPr/>
+        </p:nvSpPr>
+        <p:spPr>
+          <a:xfrm>
+            <a:off x="11094415" y="292608"/>
+            <a:ext cx="822960" cy="457200"/>
+          </a:xfrm>
+          <a:prstGeom prst="rect">
+            <a:avLst/>
+          </a:prstGeom>
+          <a:noFill/>
+        </p:spPr>
+        <p:txBody>
+          <a:bodyPr wrap="square" anchor="ctr" lIns="25400" rIns="25400" tIns="25400" bIns="25400">
+            <a:spAutoFit/>
+          </a:bodyPr>
+          <a:lstStyle/>
+          <a:p>
+            <a:pPr algn="r"/>
+            <a:r>
+              <a:rPr sz="1200">
+                <a:solidFill>
+                  <a:srgbClr val="AFC6DB"/>
+                </a:solidFill>
+                <a:latin typeface="Yu Gothic"/>
+                <a:ea typeface="Yu Gothic"/>
+              </a:rPr>
+              <a:t>7</a:t>
+            </a:r>
+          </a:p>
+        </p:txBody>
+      </p:sp>
+      <p:sp>
+        <p:nvSpPr>
+          <p:cNvPr id="7" name="Rounded Rectangle 6"/>
           <p:cNvSpPr/>
           <p:nvPr/>
         </p:nvSpPr>
         <p:spPr>
           <a:xfrm>
-            <a:off x="502920" y="274320"/>
-            <a:ext cx="1828800" cy="502920"/>
+            <a:off x="384048" y="1298448"/>
+            <a:ext cx="3657600" cy="2395728"/>
           </a:xfrm>
           <a:prstGeom prst="roundRect">
             <a:avLst>
-              <a:gd name="adj" fmla="val 50000"/>
+              <a:gd name="adj" fmla="val 4000"/>
             </a:avLst>
           </a:prstGeom>
           <a:solidFill>
-            <a:srgbClr val="35C7EC"/>
+            <a:srgbClr val="000000"/>
+          </a:solidFill>
+          <a:ln w="19050">
+            <a:solidFill>
+              <a:srgbClr val="3B6EF0"/>
+            </a:solidFill>
+          </a:ln>
+          <a:effectLst/>
+        </p:spPr>
+        <p:style>
+          <a:lnRef idx="1">
+            <a:schemeClr val="accent1"/>
+          </a:lnRef>
+          <a:fillRef idx="3">
+            <a:schemeClr val="accent1"/>
+          </a:fillRef>
+          <a:effectRef idx="2">
+            <a:schemeClr val="accent1"/>
+          </a:effectRef>
+          <a:fontRef idx="minor">
+            <a:schemeClr val="lt1"/>
+          </a:fontRef>
+        </p:style>
+        <p:txBody>
+          <a:bodyPr rtlCol="0" anchor="ctr"/>
+          <a:lstStyle/>
+          <a:p>
+            <a:pPr algn="ctr"/>
+          </a:p>
+        </p:txBody>
+      </p:sp>
+      <p:sp>
+        <p:nvSpPr>
+          <p:cNvPr id="8" name="Round Same Side Corner Rectangle 7"/>
+          <p:cNvSpPr/>
+          <p:nvPr/>
+        </p:nvSpPr>
+        <p:spPr>
+          <a:xfrm>
+            <a:off x="384048" y="1298448"/>
+            <a:ext cx="3657600" cy="457200"/>
+          </a:xfrm>
+          <a:prstGeom prst="round2SameRect">
+            <a:avLst/>
+          </a:prstGeom>
+          <a:solidFill>
+            <a:srgbClr val="3B6EF0"/>
           </a:solidFill>
           <a:ln>
             <a:noFill/>
@@ -9575,313 +10282,20 @@
       </p:sp>
       <p:sp>
         <p:nvSpPr>
-          <p:cNvPr id="6" name="TextBox 5"/>
-          <p:cNvSpPr txBox="1"/>
-          <p:nvPr/>
-        </p:nvSpPr>
-        <p:spPr>
-          <a:xfrm>
-            <a:off x="502920" y="274320"/>
-            <a:ext cx="1828800" cy="502920"/>
-          </a:xfrm>
-          <a:prstGeom prst="rect">
-            <a:avLst/>
-          </a:prstGeom>
-          <a:noFill/>
-        </p:spPr>
-        <p:txBody>
-          <a:bodyPr wrap="square" anchor="ctr" lIns="25400" rIns="25400" tIns="25400" bIns="25400">
-            <a:spAutoFit/>
-          </a:bodyPr>
-          <a:lstStyle/>
-          <a:p>
-            <a:pPr algn="ctr"/>
-            <a:r>
-              <a:rPr sz="1600" b="1">
-                <a:solidFill>
-                  <a:srgbClr val="162A47"/>
-                </a:solidFill>
-                <a:latin typeface="Yu Gothic"/>
-                <a:ea typeface="Yu Gothic"/>
-              </a:rPr>
-              <a:t>STEP 4</a:t>
-            </a:r>
-          </a:p>
-        </p:txBody>
-      </p:sp>
-      <p:sp>
-        <p:nvSpPr>
-          <p:cNvPr id="7" name="TextBox 6"/>
-          <p:cNvSpPr txBox="1"/>
-          <p:nvPr/>
-        </p:nvSpPr>
-        <p:spPr>
-          <a:xfrm>
-            <a:off x="2514600" y="0"/>
-            <a:ext cx="9219895" cy="1051560"/>
-          </a:xfrm>
-          <a:prstGeom prst="rect">
-            <a:avLst/>
-          </a:prstGeom>
-          <a:noFill/>
-        </p:spPr>
-        <p:txBody>
-          <a:bodyPr wrap="square" anchor="ctr" lIns="25400" rIns="25400" tIns="25400" bIns="25400">
-            <a:spAutoFit/>
-          </a:bodyPr>
-          <a:lstStyle/>
-          <a:p>
-            <a:pPr algn="l"/>
-            <a:r>
-              <a:rPr sz="2800" b="1">
-                <a:solidFill>
-                  <a:srgbClr val="FFFFFF"/>
-                </a:solidFill>
-                <a:latin typeface="Yu Gothic"/>
-                <a:ea typeface="Yu Gothic"/>
-              </a:rPr>
-              <a:t>全脳トラクト生成（tckgen）</a:t>
-            </a:r>
-          </a:p>
-        </p:txBody>
-      </p:sp>
-      <p:sp>
-        <p:nvSpPr>
-          <p:cNvPr id="8" name="TextBox 7"/>
-          <p:cNvSpPr txBox="1"/>
-          <p:nvPr/>
-        </p:nvSpPr>
-        <p:spPr>
-          <a:xfrm>
-            <a:off x="11094415" y="292608"/>
-            <a:ext cx="822960" cy="457200"/>
-          </a:xfrm>
-          <a:prstGeom prst="rect">
-            <a:avLst/>
-          </a:prstGeom>
-          <a:noFill/>
-        </p:spPr>
-        <p:txBody>
-          <a:bodyPr wrap="square" anchor="ctr" lIns="25400" rIns="25400" tIns="25400" bIns="25400">
-            <a:spAutoFit/>
-          </a:bodyPr>
-          <a:lstStyle/>
-          <a:p>
-            <a:pPr algn="r"/>
-            <a:r>
-              <a:rPr sz="1200">
-                <a:solidFill>
-                  <a:srgbClr val="AFC6DB"/>
-                </a:solidFill>
-                <a:latin typeface="Yu Gothic"/>
-                <a:ea typeface="Yu Gothic"/>
-              </a:rPr>
-              <a:t>7</a:t>
-            </a:r>
-          </a:p>
-        </p:txBody>
-      </p:sp>
-      <p:sp>
-        <p:nvSpPr>
-          <p:cNvPr id="9" name="TextBox 8"/>
-          <p:cNvSpPr txBox="1"/>
-          <p:nvPr/>
-        </p:nvSpPr>
-        <p:spPr>
-          <a:xfrm>
-            <a:off x="640080" y="1325880"/>
-            <a:ext cx="5212080" cy="3291840"/>
-          </a:xfrm>
-          <a:prstGeom prst="rect">
-            <a:avLst/>
-          </a:prstGeom>
-          <a:noFill/>
-        </p:spPr>
-        <p:txBody>
-          <a:bodyPr wrap="square" anchor="t" lIns="25400" rIns="25400" tIns="25400" bIns="25400">
-            <a:spAutoFit/>
-          </a:bodyPr>
-          <a:lstStyle/>
-          <a:p>
-            <a:pPr algn="l">
-              <a:lnSpc>
-                <a:spcPct val="115000"/>
-              </a:lnSpc>
-              <a:spcAft>
-                <a:spcPts val="200"/>
-              </a:spcAft>
-            </a:pPr>
-            <a:r>
-              <a:rPr sz="1600" b="1">
-                <a:solidFill>
-                  <a:srgbClr val="1F6FB2"/>
-                </a:solidFill>
-                <a:latin typeface="Yu Gothic"/>
-                <a:ea typeface="Yu Gothic"/>
-              </a:rPr>
-              <a:t>●  text editor でスクリプト作成</a:t>
-            </a:r>
-          </a:p>
-          <a:p>
-            <a:pPr algn="l">
-              <a:lnSpc>
-                <a:spcPct val="120000"/>
-              </a:lnSpc>
-              <a:spcAft>
-                <a:spcPts val="1200"/>
-              </a:spcAft>
-            </a:pPr>
-            <a:r>
-              <a:rPr sz="1400">
-                <a:solidFill>
-                  <a:srgbClr val="1B242E"/>
-                </a:solidFill>
-                <a:latin typeface="Yu Gothic"/>
-                <a:ea typeface="Yu Gothic"/>
-              </a:rPr>
-              <a:t>     tckgen_CST_L という名前でコマンドを記述</a:t>
-            </a:r>
-          </a:p>
-          <a:p>
-            <a:pPr algn="l">
-              <a:lnSpc>
-                <a:spcPct val="115000"/>
-              </a:lnSpc>
-              <a:spcAft>
-                <a:spcPts val="200"/>
-              </a:spcAft>
-            </a:pPr>
-            <a:r>
-              <a:rPr sz="1600" b="1">
-                <a:solidFill>
-                  <a:srgbClr val="1F6FB2"/>
-                </a:solidFill>
-                <a:latin typeface="Yu Gothic"/>
-                <a:ea typeface="Yu Gothic"/>
-              </a:rPr>
-              <a:t>●  シード</a:t>
-            </a:r>
-          </a:p>
-          <a:p>
-            <a:pPr algn="l">
-              <a:lnSpc>
-                <a:spcPct val="120000"/>
-              </a:lnSpc>
-              <a:spcAft>
-                <a:spcPts val="1200"/>
-              </a:spcAft>
-            </a:pPr>
-            <a:r>
-              <a:rPr sz="1400">
-                <a:solidFill>
-                  <a:srgbClr val="1B242E"/>
-                </a:solidFill>
-                <a:latin typeface="Yu Gothic"/>
-                <a:ea typeface="Yu Gothic"/>
-              </a:rPr>
-              <a:t>     gmwmSeed_coreg.mif（灰白質-白質境界）から発生</a:t>
-            </a:r>
-          </a:p>
-          <a:p>
-            <a:pPr algn="l">
-              <a:lnSpc>
-                <a:spcPct val="115000"/>
-              </a:lnSpc>
-              <a:spcAft>
-                <a:spcPts val="200"/>
-              </a:spcAft>
-            </a:pPr>
-            <a:r>
-              <a:rPr sz="1600" b="1">
-                <a:solidFill>
-                  <a:srgbClr val="1F6FB2"/>
-                </a:solidFill>
-                <a:latin typeface="Yu Gothic"/>
-                <a:ea typeface="Yu Gothic"/>
-              </a:rPr>
-              <a:t>●  ストリームライン数</a:t>
-            </a:r>
-          </a:p>
-          <a:p>
-            <a:pPr algn="l">
-              <a:lnSpc>
-                <a:spcPct val="120000"/>
-              </a:lnSpc>
-              <a:spcAft>
-                <a:spcPts val="1200"/>
-              </a:spcAft>
-            </a:pPr>
-            <a:r>
-              <a:rPr sz="1400">
-                <a:solidFill>
-                  <a:srgbClr val="1B242E"/>
-                </a:solidFill>
-                <a:latin typeface="Yu Gothic"/>
-                <a:ea typeface="Yu Gothic"/>
-              </a:rPr>
-              <a:t>     -select 1000000（100万本）を生成</a:t>
-            </a:r>
-          </a:p>
-          <a:p>
-            <a:pPr algn="l">
-              <a:lnSpc>
-                <a:spcPct val="115000"/>
-              </a:lnSpc>
-              <a:spcAft>
-                <a:spcPts val="200"/>
-              </a:spcAft>
-            </a:pPr>
-            <a:r>
-              <a:rPr sz="1600" b="1">
-                <a:solidFill>
-                  <a:srgbClr val="1F6FB2"/>
-                </a:solidFill>
-                <a:latin typeface="Yu Gothic"/>
-                <a:ea typeface="Yu Gothic"/>
-              </a:rPr>
-              <a:t>●  出力</a:t>
-            </a:r>
-          </a:p>
-          <a:p>
-            <a:pPr algn="l">
-              <a:lnSpc>
-                <a:spcPct val="120000"/>
-              </a:lnSpc>
-              <a:spcAft>
-                <a:spcPts val="1200"/>
-              </a:spcAft>
-            </a:pPr>
-            <a:r>
-              <a:rPr sz="1400">
-                <a:solidFill>
-                  <a:srgbClr val="1B242E"/>
-                </a:solidFill>
-                <a:latin typeface="Yu Gothic"/>
-                <a:ea typeface="Yu Gothic"/>
-              </a:rPr>
-              <a:t>     tracks_10bil.tck（全脳トラクト）</a:t>
-            </a:r>
-          </a:p>
-        </p:txBody>
-      </p:sp>
-      <p:sp>
-        <p:nvSpPr>
-          <p:cNvPr id="10" name="Rounded Rectangle 9"/>
+          <p:cNvPr id="9" name="Oval 8"/>
           <p:cNvSpPr/>
           <p:nvPr/>
         </p:nvSpPr>
         <p:spPr>
           <a:xfrm>
-            <a:off x="640080" y="4581144"/>
-            <a:ext cx="5212080" cy="1225295"/>
-          </a:xfrm>
-          <a:prstGeom prst="roundRect">
-            <a:avLst>
-              <a:gd name="adj" fmla="val 4000"/>
-            </a:avLst>
+            <a:off x="512064" y="1435608"/>
+            <a:ext cx="182880" cy="182880"/>
+          </a:xfrm>
+          <a:prstGeom prst="ellipse">
+            <a:avLst/>
           </a:prstGeom>
           <a:solidFill>
-            <a:srgbClr val="1E2939"/>
+            <a:srgbClr val="FFFFFF"/>
           </a:solidFill>
           <a:ln>
             <a:noFill/>
@@ -9912,20 +10326,128 @@
       </p:sp>
       <p:sp>
         <p:nvSpPr>
-          <p:cNvPr id="11" name="Oval 10"/>
+          <p:cNvPr id="10" name="TextBox 9"/>
+          <p:cNvSpPr txBox="1"/>
+          <p:nvPr/>
+        </p:nvSpPr>
+        <p:spPr>
+          <a:xfrm>
+            <a:off x="768096" y="1298448"/>
+            <a:ext cx="3200400" cy="457200"/>
+          </a:xfrm>
+          <a:prstGeom prst="rect">
+            <a:avLst/>
+          </a:prstGeom>
+          <a:noFill/>
+        </p:spPr>
+        <p:txBody>
+          <a:bodyPr wrap="square" anchor="ctr" lIns="25400" rIns="25400" tIns="25400" bIns="25400">
+            <a:spAutoFit/>
+          </a:bodyPr>
+          <a:lstStyle/>
+          <a:p>
+            <a:pPr algn="l"/>
+            <a:r>
+              <a:rPr sz="1250" b="1">
+                <a:solidFill>
+                  <a:srgbClr val="FFFFFF"/>
+                </a:solidFill>
+                <a:latin typeface="Yu Gothic"/>
+                <a:ea typeface="Yu Gothic"/>
+              </a:rPr>
+              <a:t>M1_hand_L   一次運動野・手領域</a:t>
+            </a:r>
+          </a:p>
+        </p:txBody>
+      </p:sp>
+      <p:pic>
+        <p:nvPicPr>
+          <p:cNvPr id="11" name="Picture 10" descr="roi_M1_hand_L.png"/>
+          <p:cNvPicPr>
+            <a:picLocks noChangeAspect="1"/>
+          </p:cNvPicPr>
+          <p:nvPr/>
+        </p:nvPicPr>
+        <p:blipFill>
+          <a:blip r:embed="rId2"/>
+          <a:stretch>
+            <a:fillRect/>
+          </a:stretch>
+        </p:blipFill>
+        <p:spPr>
+          <a:xfrm>
+            <a:off x="1165509" y="1801368"/>
+            <a:ext cx="2094678" cy="1819656"/>
+          </a:xfrm>
+          <a:prstGeom prst="rect">
+            <a:avLst/>
+          </a:prstGeom>
+        </p:spPr>
+      </p:pic>
+      <p:sp>
+        <p:nvSpPr>
+          <p:cNvPr id="12" name="Rounded Rectangle 11"/>
           <p:cNvSpPr/>
           <p:nvPr/>
         </p:nvSpPr>
         <p:spPr>
           <a:xfrm>
-            <a:off x="804672" y="4727448"/>
-            <a:ext cx="109728" cy="109728"/>
-          </a:xfrm>
-          <a:prstGeom prst="ellipse">
-            <a:avLst/>
+            <a:off x="4270248" y="1298448"/>
+            <a:ext cx="3657600" cy="2395728"/>
+          </a:xfrm>
+          <a:prstGeom prst="roundRect">
+            <a:avLst>
+              <a:gd name="adj" fmla="val 4000"/>
+            </a:avLst>
           </a:prstGeom>
           <a:solidFill>
-            <a:srgbClr val="FF5F57"/>
+            <a:srgbClr val="000000"/>
+          </a:solidFill>
+          <a:ln w="19050">
+            <a:solidFill>
+              <a:srgbClr val="E09B3D"/>
+            </a:solidFill>
+          </a:ln>
+          <a:effectLst/>
+        </p:spPr>
+        <p:style>
+          <a:lnRef idx="1">
+            <a:schemeClr val="accent1"/>
+          </a:lnRef>
+          <a:fillRef idx="3">
+            <a:schemeClr val="accent1"/>
+          </a:fillRef>
+          <a:effectRef idx="2">
+            <a:schemeClr val="accent1"/>
+          </a:effectRef>
+          <a:fontRef idx="minor">
+            <a:schemeClr val="lt1"/>
+          </a:fontRef>
+        </p:style>
+        <p:txBody>
+          <a:bodyPr rtlCol="0" anchor="ctr"/>
+          <a:lstStyle/>
+          <a:p>
+            <a:pPr algn="ctr"/>
+          </a:p>
+        </p:txBody>
+      </p:sp>
+      <p:sp>
+        <p:nvSpPr>
+          <p:cNvPr id="13" name="Round Same Side Corner Rectangle 12"/>
+          <p:cNvSpPr/>
+          <p:nvPr/>
+        </p:nvSpPr>
+        <p:spPr>
+          <a:xfrm>
+            <a:off x="4270248" y="1298448"/>
+            <a:ext cx="3657600" cy="457200"/>
+          </a:xfrm>
+          <a:prstGeom prst="round2SameRect">
+            <a:avLst/>
+          </a:prstGeom>
+          <a:solidFill>
+            <a:srgbClr val="E09B3D"/>
           </a:solidFill>
           <a:ln>
             <a:noFill/>
@@ -9956,20 +10478,20 @@
       </p:sp>
       <p:sp>
         <p:nvSpPr>
-          <p:cNvPr id="12" name="Oval 11"/>
+          <p:cNvPr id="14" name="Oval 13"/>
           <p:cNvSpPr/>
           <p:nvPr/>
         </p:nvSpPr>
         <p:spPr>
           <a:xfrm>
-            <a:off x="1005840" y="4727448"/>
-            <a:ext cx="109728" cy="109728"/>
+            <a:off x="4398264" y="1435608"/>
+            <a:ext cx="182880" cy="182880"/>
           </a:xfrm>
           <a:prstGeom prst="ellipse">
             <a:avLst/>
           </a:prstGeom>
           <a:solidFill>
-            <a:srgbClr val="FEBC2E"/>
+            <a:srgbClr val="FFFFFF"/>
           </a:solidFill>
           <a:ln>
             <a:noFill/>
@@ -10000,20 +10522,128 @@
       </p:sp>
       <p:sp>
         <p:nvSpPr>
-          <p:cNvPr id="13" name="Oval 12"/>
+          <p:cNvPr id="15" name="TextBox 14"/>
+          <p:cNvSpPr txBox="1"/>
+          <p:nvPr/>
+        </p:nvSpPr>
+        <p:spPr>
+          <a:xfrm>
+            <a:off x="4654296" y="1298448"/>
+            <a:ext cx="3200400" cy="457200"/>
+          </a:xfrm>
+          <a:prstGeom prst="rect">
+            <a:avLst/>
+          </a:prstGeom>
+          <a:noFill/>
+        </p:spPr>
+        <p:txBody>
+          <a:bodyPr wrap="square" anchor="ctr" lIns="25400" rIns="25400" tIns="25400" bIns="25400">
+            <a:spAutoFit/>
+          </a:bodyPr>
+          <a:lstStyle/>
+          <a:p>
+            <a:pPr algn="l"/>
+            <a:r>
+              <a:rPr sz="1250" b="1">
+                <a:solidFill>
+                  <a:srgbClr val="FFFFFF"/>
+                </a:solidFill>
+                <a:latin typeface="Yu Gothic"/>
+                <a:ea typeface="Yu Gothic"/>
+              </a:rPr>
+              <a:t>Internal_capsule_L   内包</a:t>
+            </a:r>
+          </a:p>
+        </p:txBody>
+      </p:sp>
+      <p:pic>
+        <p:nvPicPr>
+          <p:cNvPr id="16" name="Picture 15" descr="roi_Internal_capsule_L.png"/>
+          <p:cNvPicPr>
+            <a:picLocks noChangeAspect="1"/>
+          </p:cNvPicPr>
+          <p:nvPr/>
+        </p:nvPicPr>
+        <p:blipFill>
+          <a:blip r:embed="rId3"/>
+          <a:stretch>
+            <a:fillRect/>
+          </a:stretch>
+        </p:blipFill>
+        <p:spPr>
+          <a:xfrm>
+            <a:off x="4866219" y="1801368"/>
+            <a:ext cx="2465658" cy="1819656"/>
+          </a:xfrm>
+          <a:prstGeom prst="rect">
+            <a:avLst/>
+          </a:prstGeom>
+        </p:spPr>
+      </p:pic>
+      <p:sp>
+        <p:nvSpPr>
+          <p:cNvPr id="17" name="Rounded Rectangle 16"/>
           <p:cNvSpPr/>
           <p:nvPr/>
         </p:nvSpPr>
         <p:spPr>
           <a:xfrm>
-            <a:off x="1207008" y="4727448"/>
-            <a:ext cx="109728" cy="109728"/>
-          </a:xfrm>
-          <a:prstGeom prst="ellipse">
-            <a:avLst/>
+            <a:off x="8156448" y="1298448"/>
+            <a:ext cx="3657600" cy="2395728"/>
+          </a:xfrm>
+          <a:prstGeom prst="roundRect">
+            <a:avLst>
+              <a:gd name="adj" fmla="val 4000"/>
+            </a:avLst>
           </a:prstGeom>
           <a:solidFill>
-            <a:srgbClr val="28C840"/>
+            <a:srgbClr val="000000"/>
+          </a:solidFill>
+          <a:ln w="19050">
+            <a:solidFill>
+              <a:srgbClr val="2FC2D6"/>
+            </a:solidFill>
+          </a:ln>
+          <a:effectLst/>
+        </p:spPr>
+        <p:style>
+          <a:lnRef idx="1">
+            <a:schemeClr val="accent1"/>
+          </a:lnRef>
+          <a:fillRef idx="3">
+            <a:schemeClr val="accent1"/>
+          </a:fillRef>
+          <a:effectRef idx="2">
+            <a:schemeClr val="accent1"/>
+          </a:effectRef>
+          <a:fontRef idx="minor">
+            <a:schemeClr val="lt1"/>
+          </a:fontRef>
+        </p:style>
+        <p:txBody>
+          <a:bodyPr rtlCol="0" anchor="ctr"/>
+          <a:lstStyle/>
+          <a:p>
+            <a:pPr algn="ctr"/>
+          </a:p>
+        </p:txBody>
+      </p:sp>
+      <p:sp>
+        <p:nvSpPr>
+          <p:cNvPr id="18" name="Round Same Side Corner Rectangle 17"/>
+          <p:cNvSpPr/>
+          <p:nvPr/>
+        </p:nvSpPr>
+        <p:spPr>
+          <a:xfrm>
+            <a:off x="8156448" y="1298448"/>
+            <a:ext cx="3657600" cy="457200"/>
+          </a:xfrm>
+          <a:prstGeom prst="round2SameRect">
+            <a:avLst/>
+          </a:prstGeom>
+          <a:solidFill>
+            <a:srgbClr val="2FC2D6"/>
           </a:solidFill>
           <a:ln>
             <a:noFill/>
@@ -10044,150 +10674,23 @@
       </p:sp>
       <p:sp>
         <p:nvSpPr>
-          <p:cNvPr id="14" name="TextBox 13"/>
-          <p:cNvSpPr txBox="1"/>
-          <p:nvPr/>
-        </p:nvSpPr>
-        <p:spPr>
-          <a:xfrm>
-            <a:off x="822960" y="4965192"/>
-            <a:ext cx="4846320" cy="722375"/>
-          </a:xfrm>
-          <a:prstGeom prst="rect">
-            <a:avLst/>
-          </a:prstGeom>
-          <a:noFill/>
-        </p:spPr>
-        <p:txBody>
-          <a:bodyPr wrap="square">
-            <a:spAutoFit/>
-          </a:bodyPr>
-          <a:lstStyle/>
-          <a:p>
-            <a:pPr>
-              <a:lnSpc>
-                <a:spcPct val="110000"/>
-              </a:lnSpc>
-              <a:spcAft>
-                <a:spcPts val="300"/>
-              </a:spcAft>
-            </a:pPr>
-            <a:r>
-              <a:rPr sz="1300" b="1">
-                <a:solidFill>
-                  <a:srgbClr val="35C7EC"/>
-                </a:solidFill>
-                <a:latin typeface="Consolas"/>
-                <a:ea typeface="Consolas"/>
-              </a:rPr>
-              <a:t>$ </a:t>
-            </a:r>
-            <a:r>
-              <a:rPr sz="1300" b="0">
-                <a:solidFill>
-                  <a:srgbClr val="CBE6FF"/>
-                </a:solidFill>
-                <a:latin typeface="Consolas"/>
-                <a:ea typeface="Consolas"/>
-              </a:rPr>
-              <a:t>tckgen gmwmSeed_coreg.mif -select 1000000 \</a:t>
-            </a:r>
-          </a:p>
-          <a:p>
-            <a:pPr>
-              <a:lnSpc>
-                <a:spcPct val="110000"/>
-              </a:lnSpc>
-              <a:spcAft>
-                <a:spcPts val="300"/>
-              </a:spcAft>
-            </a:pPr>
-            <a:r>
-              <a:rPr sz="1300" b="1">
-                <a:solidFill>
-                  <a:srgbClr val="35C7EC"/>
-                </a:solidFill>
-                <a:latin typeface="Consolas"/>
-                <a:ea typeface="Consolas"/>
-              </a:rPr>
-              <a:t>$ </a:t>
-            </a:r>
-            <a:r>
-              <a:rPr sz="1300" b="0">
-                <a:solidFill>
-                  <a:srgbClr val="CBE6FF"/>
-                </a:solidFill>
-                <a:latin typeface="Consolas"/>
-                <a:ea typeface="Consolas"/>
-              </a:rPr>
-              <a:t>       wmfod_norm.mif tracks_10bil.tck</a:t>
-            </a:r>
-          </a:p>
-        </p:txBody>
-      </p:sp>
-      <p:sp>
-        <p:nvSpPr>
-          <p:cNvPr id="15" name="TextBox 14"/>
-          <p:cNvSpPr txBox="1"/>
-          <p:nvPr/>
-        </p:nvSpPr>
-        <p:spPr>
-          <a:xfrm>
-            <a:off x="640080" y="5989320"/>
-            <a:ext cx="5212080" cy="640080"/>
-          </a:xfrm>
-          <a:prstGeom prst="rect">
-            <a:avLst/>
-          </a:prstGeom>
-          <a:noFill/>
-        </p:spPr>
-        <p:txBody>
-          <a:bodyPr wrap="square" anchor="t" lIns="25400" rIns="25400" tIns="25400" bIns="25400">
-            <a:spAutoFit/>
-          </a:bodyPr>
-          <a:lstStyle/>
-          <a:p>
-            <a:pPr algn="l">
-              <a:lnSpc>
-                <a:spcPct val="115000"/>
-              </a:lnSpc>
-            </a:pPr>
-            <a:r>
-              <a:rPr sz="1200" i="1">
-                <a:solidFill>
-                  <a:srgbClr val="5A6B7B"/>
-                </a:solidFill>
-                <a:latin typeface="Yu Gothic"/>
-                <a:ea typeface="Yu Gothic"/>
-              </a:rPr>
-              <a:t>📝 まずは全脳のストリームラインをまとめて生成しておく。</a:t>
-            </a:r>
-          </a:p>
-        </p:txBody>
-      </p:sp>
-      <p:sp>
-        <p:nvSpPr>
-          <p:cNvPr id="16" name="Rounded Rectangle 15"/>
+          <p:cNvPr id="19" name="Oval 18"/>
           <p:cNvSpPr/>
           <p:nvPr/>
         </p:nvSpPr>
         <p:spPr>
           <a:xfrm>
-            <a:off x="6126480" y="1325880"/>
-            <a:ext cx="5440680" cy="4937760"/>
-          </a:xfrm>
-          <a:prstGeom prst="roundRect">
-            <a:avLst>
-              <a:gd name="adj" fmla="val 3000"/>
-            </a:avLst>
+            <a:off x="8284464" y="1435608"/>
+            <a:ext cx="182880" cy="182880"/>
+          </a:xfrm>
+          <a:prstGeom prst="ellipse">
+            <a:avLst/>
           </a:prstGeom>
           <a:solidFill>
-            <a:srgbClr val="E6ECF2"/>
+            <a:srgbClr val="FFFFFF"/>
           </a:solidFill>
-          <a:ln w="15875">
-            <a:solidFill>
-              <a:srgbClr val="B4C2D0"/>
-            </a:solidFill>
+          <a:ln>
+            <a:noFill/>
           </a:ln>
           <a:effectLst/>
         </p:spPr>
@@ -10215,14 +10718,14 @@
       </p:sp>
       <p:sp>
         <p:nvSpPr>
-          <p:cNvPr id="17" name="TextBox 16"/>
+          <p:cNvPr id="20" name="TextBox 19"/>
           <p:cNvSpPr txBox="1"/>
           <p:nvPr/>
         </p:nvSpPr>
         <p:spPr>
           <a:xfrm>
-            <a:off x="6126480" y="1325880"/>
-            <a:ext cx="5440680" cy="4937760"/>
+            <a:off x="8540496" y="1298448"/>
+            <a:ext cx="3200400" cy="457200"/>
           </a:xfrm>
           <a:prstGeom prst="rect">
             <a:avLst/>
@@ -10235,33 +10738,468 @@
           </a:bodyPr>
           <a:lstStyle/>
           <a:p>
-            <a:pPr algn="ctr">
-              <a:spcAft>
-                <a:spcPts val="400"/>
-              </a:spcAft>
-            </a:pPr>
-            <a:r>
-              <a:rPr sz="3000">
-                <a:solidFill>
-                  <a:srgbClr val="B4C2D0"/>
-                </a:solidFill>
-                <a:latin typeface="Yu Gothic"/>
-                <a:ea typeface="Yu Gothic"/>
-              </a:rPr>
-              <a:t>🖼</a:t>
-            </a:r>
-          </a:p>
+            <a:pPr algn="l"/>
+            <a:r>
+              <a:rPr sz="1250" b="1">
+                <a:solidFill>
+                  <a:srgbClr val="FFFFFF"/>
+                </a:solidFill>
+                <a:latin typeface="Yu Gothic"/>
+                <a:ea typeface="Yu Gothic"/>
+              </a:rPr>
+              <a:t>Cerebral_peduncle_L   大脳脚</a:t>
+            </a:r>
+          </a:p>
+        </p:txBody>
+      </p:sp>
+      <p:pic>
+        <p:nvPicPr>
+          <p:cNvPr id="21" name="Picture 20" descr="roi_Cerebral_peduncle_L.png"/>
+          <p:cNvPicPr>
+            <a:picLocks noChangeAspect="1"/>
+          </p:cNvPicPr>
+          <p:nvPr/>
+        </p:nvPicPr>
+        <p:blipFill>
+          <a:blip r:embed="rId4"/>
+          <a:stretch>
+            <a:fillRect/>
+          </a:stretch>
+        </p:blipFill>
+        <p:spPr>
+          <a:xfrm>
+            <a:off x="8752419" y="1801368"/>
+            <a:ext cx="2465658" cy="1819656"/>
+          </a:xfrm>
+          <a:prstGeom prst="rect">
+            <a:avLst/>
+          </a:prstGeom>
+        </p:spPr>
+      </p:pic>
+      <p:sp>
+        <p:nvSpPr>
+          <p:cNvPr id="22" name="Rounded Rectangle 21"/>
+          <p:cNvSpPr/>
+          <p:nvPr/>
+        </p:nvSpPr>
+        <p:spPr>
+          <a:xfrm>
+            <a:off x="2323947" y="3858768"/>
+            <a:ext cx="3657600" cy="2395728"/>
+          </a:xfrm>
+          <a:prstGeom prst="roundRect">
+            <a:avLst>
+              <a:gd name="adj" fmla="val 4000"/>
+            </a:avLst>
+          </a:prstGeom>
+          <a:solidFill>
+            <a:srgbClr val="000000"/>
+          </a:solidFill>
+          <a:ln w="19050">
+            <a:solidFill>
+              <a:srgbClr val="3B6EF0"/>
+            </a:solidFill>
+          </a:ln>
+          <a:effectLst/>
+        </p:spPr>
+        <p:style>
+          <a:lnRef idx="1">
+            <a:schemeClr val="accent1"/>
+          </a:lnRef>
+          <a:fillRef idx="3">
+            <a:schemeClr val="accent1"/>
+          </a:fillRef>
+          <a:effectRef idx="2">
+            <a:schemeClr val="accent1"/>
+          </a:effectRef>
+          <a:fontRef idx="minor">
+            <a:schemeClr val="lt1"/>
+          </a:fontRef>
+        </p:style>
+        <p:txBody>
+          <a:bodyPr rtlCol="0" anchor="ctr"/>
+          <a:lstStyle/>
           <a:p>
             <a:pPr algn="ctr"/>
-            <a:r>
-              <a:rPr sz="1300" b="1">
-                <a:solidFill>
-                  <a:srgbClr val="5A6B7B"/>
-                </a:solidFill>
-                <a:latin typeface="Yu Gothic"/>
-                <a:ea typeface="Yu Gothic"/>
-              </a:rPr>
-              <a:t>text editor / コマンド記述のスクショ</a:t>
+          </a:p>
+        </p:txBody>
+      </p:sp>
+      <p:sp>
+        <p:nvSpPr>
+          <p:cNvPr id="23" name="Round Same Side Corner Rectangle 22"/>
+          <p:cNvSpPr/>
+          <p:nvPr/>
+        </p:nvSpPr>
+        <p:spPr>
+          <a:xfrm>
+            <a:off x="2323947" y="3858768"/>
+            <a:ext cx="3657600" cy="457200"/>
+          </a:xfrm>
+          <a:prstGeom prst="round2SameRect">
+            <a:avLst/>
+          </a:prstGeom>
+          <a:solidFill>
+            <a:srgbClr val="3B6EF0"/>
+          </a:solidFill>
+          <a:ln>
+            <a:noFill/>
+          </a:ln>
+          <a:effectLst/>
+        </p:spPr>
+        <p:style>
+          <a:lnRef idx="1">
+            <a:schemeClr val="accent1"/>
+          </a:lnRef>
+          <a:fillRef idx="3">
+            <a:schemeClr val="accent1"/>
+          </a:fillRef>
+          <a:effectRef idx="2">
+            <a:schemeClr val="accent1"/>
+          </a:effectRef>
+          <a:fontRef idx="minor">
+            <a:schemeClr val="lt1"/>
+          </a:fontRef>
+        </p:style>
+        <p:txBody>
+          <a:bodyPr rtlCol="0" anchor="ctr"/>
+          <a:lstStyle/>
+          <a:p>
+            <a:pPr algn="ctr"/>
+          </a:p>
+        </p:txBody>
+      </p:sp>
+      <p:sp>
+        <p:nvSpPr>
+          <p:cNvPr id="24" name="Oval 23"/>
+          <p:cNvSpPr/>
+          <p:nvPr/>
+        </p:nvSpPr>
+        <p:spPr>
+          <a:xfrm>
+            <a:off x="2451963" y="3995928"/>
+            <a:ext cx="182880" cy="182880"/>
+          </a:xfrm>
+          <a:prstGeom prst="ellipse">
+            <a:avLst/>
+          </a:prstGeom>
+          <a:solidFill>
+            <a:srgbClr val="FFFFFF"/>
+          </a:solidFill>
+          <a:ln>
+            <a:noFill/>
+          </a:ln>
+          <a:effectLst/>
+        </p:spPr>
+        <p:style>
+          <a:lnRef idx="1">
+            <a:schemeClr val="accent1"/>
+          </a:lnRef>
+          <a:fillRef idx="3">
+            <a:schemeClr val="accent1"/>
+          </a:fillRef>
+          <a:effectRef idx="2">
+            <a:schemeClr val="accent1"/>
+          </a:effectRef>
+          <a:fontRef idx="minor">
+            <a:schemeClr val="lt1"/>
+          </a:fontRef>
+        </p:style>
+        <p:txBody>
+          <a:bodyPr rtlCol="0" anchor="ctr"/>
+          <a:lstStyle/>
+          <a:p>
+            <a:pPr algn="ctr"/>
+          </a:p>
+        </p:txBody>
+      </p:sp>
+      <p:sp>
+        <p:nvSpPr>
+          <p:cNvPr id="25" name="TextBox 24"/>
+          <p:cNvSpPr txBox="1"/>
+          <p:nvPr/>
+        </p:nvSpPr>
+        <p:spPr>
+          <a:xfrm>
+            <a:off x="2707995" y="3858768"/>
+            <a:ext cx="3200400" cy="457200"/>
+          </a:xfrm>
+          <a:prstGeom prst="rect">
+            <a:avLst/>
+          </a:prstGeom>
+          <a:noFill/>
+        </p:spPr>
+        <p:txBody>
+          <a:bodyPr wrap="square" anchor="ctr" lIns="25400" rIns="25400" tIns="25400" bIns="25400">
+            <a:spAutoFit/>
+          </a:bodyPr>
+          <a:lstStyle/>
+          <a:p>
+            <a:pPr algn="l"/>
+            <a:r>
+              <a:rPr sz="1250" b="1">
+                <a:solidFill>
+                  <a:srgbClr val="FFFFFF"/>
+                </a:solidFill>
+                <a:latin typeface="Yu Gothic"/>
+                <a:ea typeface="Yu Gothic"/>
+              </a:rPr>
+              <a:t>Pons_L   橋</a:t>
+            </a:r>
+          </a:p>
+        </p:txBody>
+      </p:sp>
+      <p:pic>
+        <p:nvPicPr>
+          <p:cNvPr id="26" name="Picture 25" descr="roi_Pons_L.png"/>
+          <p:cNvPicPr>
+            <a:picLocks noChangeAspect="1"/>
+          </p:cNvPicPr>
+          <p:nvPr/>
+        </p:nvPicPr>
+        <p:blipFill>
+          <a:blip r:embed="rId5"/>
+          <a:stretch>
+            <a:fillRect/>
+          </a:stretch>
+        </p:blipFill>
+        <p:spPr>
+          <a:xfrm>
+            <a:off x="2919918" y="4361688"/>
+            <a:ext cx="2465658" cy="1819656"/>
+          </a:xfrm>
+          <a:prstGeom prst="rect">
+            <a:avLst/>
+          </a:prstGeom>
+        </p:spPr>
+      </p:pic>
+      <p:sp>
+        <p:nvSpPr>
+          <p:cNvPr id="27" name="Rounded Rectangle 26"/>
+          <p:cNvSpPr/>
+          <p:nvPr/>
+        </p:nvSpPr>
+        <p:spPr>
+          <a:xfrm>
+            <a:off x="6210147" y="3858768"/>
+            <a:ext cx="3657600" cy="2395728"/>
+          </a:xfrm>
+          <a:prstGeom prst="roundRect">
+            <a:avLst>
+              <a:gd name="adj" fmla="val 4000"/>
+            </a:avLst>
+          </a:prstGeom>
+          <a:solidFill>
+            <a:srgbClr val="000000"/>
+          </a:solidFill>
+          <a:ln w="19050">
+            <a:solidFill>
+              <a:srgbClr val="6A55D0"/>
+            </a:solidFill>
+          </a:ln>
+          <a:effectLst/>
+        </p:spPr>
+        <p:style>
+          <a:lnRef idx="1">
+            <a:schemeClr val="accent1"/>
+          </a:lnRef>
+          <a:fillRef idx="3">
+            <a:schemeClr val="accent1"/>
+          </a:fillRef>
+          <a:effectRef idx="2">
+            <a:schemeClr val="accent1"/>
+          </a:effectRef>
+          <a:fontRef idx="minor">
+            <a:schemeClr val="lt1"/>
+          </a:fontRef>
+        </p:style>
+        <p:txBody>
+          <a:bodyPr rtlCol="0" anchor="ctr"/>
+          <a:lstStyle/>
+          <a:p>
+            <a:pPr algn="ctr"/>
+          </a:p>
+        </p:txBody>
+      </p:sp>
+      <p:sp>
+        <p:nvSpPr>
+          <p:cNvPr id="28" name="Round Same Side Corner Rectangle 27"/>
+          <p:cNvSpPr/>
+          <p:nvPr/>
+        </p:nvSpPr>
+        <p:spPr>
+          <a:xfrm>
+            <a:off x="6210147" y="3858768"/>
+            <a:ext cx="3657600" cy="457200"/>
+          </a:xfrm>
+          <a:prstGeom prst="round2SameRect">
+            <a:avLst/>
+          </a:prstGeom>
+          <a:solidFill>
+            <a:srgbClr val="6A55D0"/>
+          </a:solidFill>
+          <a:ln>
+            <a:noFill/>
+          </a:ln>
+          <a:effectLst/>
+        </p:spPr>
+        <p:style>
+          <a:lnRef idx="1">
+            <a:schemeClr val="accent1"/>
+          </a:lnRef>
+          <a:fillRef idx="3">
+            <a:schemeClr val="accent1"/>
+          </a:fillRef>
+          <a:effectRef idx="2">
+            <a:schemeClr val="accent1"/>
+          </a:effectRef>
+          <a:fontRef idx="minor">
+            <a:schemeClr val="lt1"/>
+          </a:fontRef>
+        </p:style>
+        <p:txBody>
+          <a:bodyPr rtlCol="0" anchor="ctr"/>
+          <a:lstStyle/>
+          <a:p>
+            <a:pPr algn="ctr"/>
+          </a:p>
+        </p:txBody>
+      </p:sp>
+      <p:sp>
+        <p:nvSpPr>
+          <p:cNvPr id="29" name="Oval 28"/>
+          <p:cNvSpPr/>
+          <p:nvPr/>
+        </p:nvSpPr>
+        <p:spPr>
+          <a:xfrm>
+            <a:off x="6338163" y="3995928"/>
+            <a:ext cx="182880" cy="182880"/>
+          </a:xfrm>
+          <a:prstGeom prst="ellipse">
+            <a:avLst/>
+          </a:prstGeom>
+          <a:solidFill>
+            <a:srgbClr val="FFFFFF"/>
+          </a:solidFill>
+          <a:ln>
+            <a:noFill/>
+          </a:ln>
+          <a:effectLst/>
+        </p:spPr>
+        <p:style>
+          <a:lnRef idx="1">
+            <a:schemeClr val="accent1"/>
+          </a:lnRef>
+          <a:fillRef idx="3">
+            <a:schemeClr val="accent1"/>
+          </a:fillRef>
+          <a:effectRef idx="2">
+            <a:schemeClr val="accent1"/>
+          </a:effectRef>
+          <a:fontRef idx="minor">
+            <a:schemeClr val="lt1"/>
+          </a:fontRef>
+        </p:style>
+        <p:txBody>
+          <a:bodyPr rtlCol="0" anchor="ctr"/>
+          <a:lstStyle/>
+          <a:p>
+            <a:pPr algn="ctr"/>
+          </a:p>
+        </p:txBody>
+      </p:sp>
+      <p:sp>
+        <p:nvSpPr>
+          <p:cNvPr id="30" name="TextBox 29"/>
+          <p:cNvSpPr txBox="1"/>
+          <p:nvPr/>
+        </p:nvSpPr>
+        <p:spPr>
+          <a:xfrm>
+            <a:off x="6594195" y="3858768"/>
+            <a:ext cx="3200400" cy="457200"/>
+          </a:xfrm>
+          <a:prstGeom prst="rect">
+            <a:avLst/>
+          </a:prstGeom>
+          <a:noFill/>
+        </p:spPr>
+        <p:txBody>
+          <a:bodyPr wrap="square" anchor="ctr" lIns="25400" rIns="25400" tIns="25400" bIns="25400">
+            <a:spAutoFit/>
+          </a:bodyPr>
+          <a:lstStyle/>
+          <a:p>
+            <a:pPr algn="l"/>
+            <a:r>
+              <a:rPr sz="1250" b="1">
+                <a:solidFill>
+                  <a:srgbClr val="FFFFFF"/>
+                </a:solidFill>
+                <a:latin typeface="Yu Gothic"/>
+                <a:ea typeface="Yu Gothic"/>
+              </a:rPr>
+              <a:t>Medulla_L   延髄</a:t>
+            </a:r>
+          </a:p>
+        </p:txBody>
+      </p:sp>
+      <p:pic>
+        <p:nvPicPr>
+          <p:cNvPr id="31" name="Picture 30" descr="roi_Medulla_L.png"/>
+          <p:cNvPicPr>
+            <a:picLocks noChangeAspect="1"/>
+          </p:cNvPicPr>
+          <p:nvPr/>
+        </p:nvPicPr>
+        <p:blipFill>
+          <a:blip r:embed="rId6"/>
+          <a:stretch>
+            <a:fillRect/>
+          </a:stretch>
+        </p:blipFill>
+        <p:spPr>
+          <a:xfrm>
+            <a:off x="6806118" y="4361688"/>
+            <a:ext cx="2465658" cy="1819656"/>
+          </a:xfrm>
+          <a:prstGeom prst="rect">
+            <a:avLst/>
+          </a:prstGeom>
+        </p:spPr>
+      </p:pic>
+      <p:sp>
+        <p:nvSpPr>
+          <p:cNvPr id="32" name="TextBox 31"/>
+          <p:cNvSpPr txBox="1"/>
+          <p:nvPr/>
+        </p:nvSpPr>
+        <p:spPr>
+          <a:xfrm>
+            <a:off x="502920" y="6355080"/>
+            <a:ext cx="11155680" cy="411480"/>
+          </a:xfrm>
+          <a:prstGeom prst="rect">
+            <a:avLst/>
+          </a:prstGeom>
+          <a:noFill/>
+        </p:spPr>
+        <p:txBody>
+          <a:bodyPr wrap="square" anchor="ctr" lIns="25400" rIns="25400" tIns="25400" bIns="25400">
+            <a:spAutoFit/>
+          </a:bodyPr>
+          <a:lstStyle/>
+          <a:p>
+            <a:pPr algn="l"/>
+            <a:r>
+              <a:rPr sz="1100">
+                <a:solidFill>
+                  <a:srgbClr val="9DB4C8"/>
+                </a:solidFill>
+                <a:latin typeface="Yu Gothic"/>
+                <a:ea typeface="Yu Gothic"/>
+              </a:rPr>
+              <a:t>※ 各 ROI を mrview の ROI Editor で塗り、&lt;領域&gt;_L.mif として保存（解剖参照：Kandel）。脳幹3領域（大脳脚・橋・延髄）の対応は要確認。</a:t>
             </a:r>
           </a:p>
         </p:txBody>
@@ -10493,7 +11431,7 @@
                 <a:latin typeface="Yu Gothic"/>
                 <a:ea typeface="Yu Gothic"/>
               </a:rPr>
-              <a:t>STEP 5</a:t>
+              <a:t>STEP 4</a:t>
             </a:r>
           </a:p>
         </p:txBody>
@@ -10529,7 +11467,7 @@
                 <a:latin typeface="Yu Gothic"/>
                 <a:ea typeface="Yu Gothic"/>
               </a:rPr>
-              <a:t>ROI で絞り込む（tckedit）</a:t>
+              <a:t>全脳トラクト生成（tckgen）</a:t>
             </a:r>
           </a:p>
         </p:txBody>
@@ -10608,7 +11546,7 @@
                 <a:latin typeface="Yu Gothic"/>
                 <a:ea typeface="Yu Gothic"/>
               </a:rPr>
-              <a:t>●  include で通過条件を指定</a:t>
+              <a:t>●  text editor でスクリプト作成</a:t>
             </a:r>
           </a:p>
           <a:p>
@@ -10628,7 +11566,7 @@
                 <a:latin typeface="Yu Gothic"/>
                 <a:ea typeface="Yu Gothic"/>
               </a:rPr>
-              <a:t>     5つの ROI を全て通る神経だけを残す</a:t>
+              <a:t>     tckgen_CST_L という名前でコマンドを記述</a:t>
             </a:r>
           </a:p>
           <a:p>
@@ -10648,7 +11586,7 @@
                 <a:latin typeface="Yu Gothic"/>
                 <a:ea typeface="Yu Gothic"/>
               </a:rPr>
-              <a:t>●  入力</a:t>
+              <a:t>●  シード</a:t>
             </a:r>
           </a:p>
           <a:p>
@@ -10668,7 +11606,7 @@
                 <a:latin typeface="Yu Gothic"/>
                 <a:ea typeface="Yu Gothic"/>
               </a:rPr>
-              <a:t>     tracks_10bil.tck（全脳トラクト）</a:t>
+              <a:t>     gmwmSeed_coreg.mif（灰白質-白質境界）から発生</a:t>
             </a:r>
           </a:p>
           <a:p>
@@ -10688,7 +11626,7 @@
                 <a:latin typeface="Yu Gothic"/>
                 <a:ea typeface="Yu Gothic"/>
               </a:rPr>
-              <a:t>●  出力</a:t>
+              <a:t>●  ストリームライン数</a:t>
             </a:r>
           </a:p>
           <a:p>
@@ -10708,7 +11646,7 @@
                 <a:latin typeface="Yu Gothic"/>
                 <a:ea typeface="Yu Gothic"/>
               </a:rPr>
-              <a:t>     tracks_CST.tck（CST のみ）</a:t>
+              <a:t>     -select 1000000（100万本）を生成</a:t>
             </a:r>
           </a:p>
           <a:p>
@@ -10728,7 +11666,7 @@
                 <a:latin typeface="Yu Gothic"/>
                 <a:ea typeface="Yu Gothic"/>
               </a:rPr>
-              <a:t>●  実行</a:t>
+              <a:t>●  出力</a:t>
             </a:r>
           </a:p>
           <a:p>
@@ -10748,7 +11686,7 @@
                 <a:latin typeface="Yu Gothic"/>
                 <a:ea typeface="Yu Gothic"/>
               </a:rPr>
-              <a:t>     bash でスクリプトを指定して走らせる</a:t>
+              <a:t>     tracks_10bil.tck（全脳トラクト）</a:t>
             </a:r>
           </a:p>
         </p:txBody>
@@ -10761,8 +11699,8 @@
         </p:nvSpPr>
         <p:spPr>
           <a:xfrm>
-            <a:off x="640080" y="3977639"/>
-            <a:ext cx="5212080" cy="2377440"/>
+            <a:off x="640080" y="4581144"/>
+            <a:ext cx="5212080" cy="1225295"/>
           </a:xfrm>
           <a:prstGeom prst="roundRect">
             <a:avLst>
@@ -10807,7 +11745,7 @@
         </p:nvSpPr>
         <p:spPr>
           <a:xfrm>
-            <a:off x="804672" y="4123943"/>
+            <a:off x="804672" y="4727448"/>
             <a:ext cx="109728" cy="109728"/>
           </a:xfrm>
           <a:prstGeom prst="ellipse">
@@ -10851,7 +11789,7 @@
         </p:nvSpPr>
         <p:spPr>
           <a:xfrm>
-            <a:off x="1005840" y="4123943"/>
+            <a:off x="1005840" y="4727448"/>
             <a:ext cx="109728" cy="109728"/>
           </a:xfrm>
           <a:prstGeom prst="ellipse">
@@ -10895,7 +11833,7 @@
         </p:nvSpPr>
         <p:spPr>
           <a:xfrm>
-            <a:off x="1207008" y="4123943"/>
+            <a:off x="1207008" y="4727448"/>
             <a:ext cx="109728" cy="109728"/>
           </a:xfrm>
           <a:prstGeom prst="ellipse">
@@ -10939,8 +11877,8 @@
         </p:nvSpPr>
         <p:spPr>
           <a:xfrm>
-            <a:off x="822960" y="4361687"/>
-            <a:ext cx="4846320" cy="1874520"/>
+            <a:off x="822960" y="4965192"/>
+            <a:ext cx="4846320" cy="722375"/>
           </a:xfrm>
           <a:prstGeom prst="rect">
             <a:avLst/>
@@ -10979,7 +11917,7 @@
                 <a:latin typeface="Consolas"/>
                 <a:ea typeface="Consolas"/>
               </a:rPr>
-              <a:t>tckedit -include Medulla_L.mif -include Pons_L.mif \</a:t>
+              <a:t>tckgen gmwmSeed_coreg.mif -select 1000000 \</a:t>
             </a:r>
           </a:p>
           <a:p>
@@ -11009,104 +11947,54 @@
                 <a:latin typeface="Consolas"/>
                 <a:ea typeface="Consolas"/>
               </a:rPr>
-              <a:t>  -include Cerebral_peduncle_L.mif \</a:t>
-            </a:r>
-          </a:p>
-          <a:p>
-            <a:pPr>
+              <a:t>       wmfod_norm.mif tracks_10bil.tck</a:t>
+            </a:r>
+          </a:p>
+        </p:txBody>
+      </p:sp>
+      <p:sp>
+        <p:nvSpPr>
+          <p:cNvPr id="15" name="TextBox 14"/>
+          <p:cNvSpPr txBox="1"/>
+          <p:nvPr/>
+        </p:nvSpPr>
+        <p:spPr>
+          <a:xfrm>
+            <a:off x="640080" y="5989320"/>
+            <a:ext cx="5212080" cy="640080"/>
+          </a:xfrm>
+          <a:prstGeom prst="rect">
+            <a:avLst/>
+          </a:prstGeom>
+          <a:noFill/>
+        </p:spPr>
+        <p:txBody>
+          <a:bodyPr wrap="square" anchor="t" lIns="25400" rIns="25400" tIns="25400" bIns="25400">
+            <a:spAutoFit/>
+          </a:bodyPr>
+          <a:lstStyle/>
+          <a:p>
+            <a:pPr algn="l">
               <a:lnSpc>
-                <a:spcPct val="110000"/>
+                <a:spcPct val="115000"/>
               </a:lnSpc>
-              <a:spcAft>
-                <a:spcPts val="300"/>
-              </a:spcAft>
             </a:pPr>
             <a:r>
-              <a:rPr sz="1300" b="1">
-                <a:solidFill>
-                  <a:srgbClr val="35C7EC"/>
-                </a:solidFill>
-                <a:latin typeface="Consolas"/>
-                <a:ea typeface="Consolas"/>
-              </a:rPr>
-              <a:t>$ </a:t>
-            </a:r>
-            <a:r>
-              <a:rPr sz="1300" b="0">
-                <a:solidFill>
-                  <a:srgbClr val="CBE6FF"/>
-                </a:solidFill>
-                <a:latin typeface="Consolas"/>
-                <a:ea typeface="Consolas"/>
-              </a:rPr>
-              <a:t>  -include Internal_capsule_L.mif -include M1_hand_L.mif \</a:t>
-            </a:r>
-          </a:p>
-          <a:p>
-            <a:pPr>
-              <a:lnSpc>
-                <a:spcPct val="110000"/>
-              </a:lnSpc>
-              <a:spcAft>
-                <a:spcPts val="300"/>
-              </a:spcAft>
-            </a:pPr>
-            <a:r>
-              <a:rPr sz="1300" b="1">
-                <a:solidFill>
-                  <a:srgbClr val="35C7EC"/>
-                </a:solidFill>
-                <a:latin typeface="Consolas"/>
-                <a:ea typeface="Consolas"/>
-              </a:rPr>
-              <a:t>$ </a:t>
-            </a:r>
-            <a:r>
-              <a:rPr sz="1300" b="0">
-                <a:solidFill>
-                  <a:srgbClr val="CBE6FF"/>
-                </a:solidFill>
-                <a:latin typeface="Consolas"/>
-                <a:ea typeface="Consolas"/>
-              </a:rPr>
-              <a:t>  tracks_10bil.tck tracks_CST.tck</a:t>
-            </a:r>
-          </a:p>
-          <a:p>
-            <a:pPr>
-              <a:lnSpc>
-                <a:spcPct val="110000"/>
-              </a:lnSpc>
-              <a:spcAft>
-                <a:spcPts val="300"/>
-              </a:spcAft>
-            </a:pPr>
-            <a:r>
-              <a:rPr sz="1300" b="1">
-                <a:solidFill>
-                  <a:srgbClr val="35C7EC"/>
-                </a:solidFill>
-                <a:latin typeface="Consolas"/>
-                <a:ea typeface="Consolas"/>
-              </a:rPr>
-              <a:t>$ </a:t>
-            </a:r>
-            <a:r>
-              <a:rPr sz="1300" b="0">
-                <a:solidFill>
-                  <a:srgbClr val="CBE6FF"/>
-                </a:solidFill>
-                <a:latin typeface="Consolas"/>
-                <a:ea typeface="Consolas"/>
-              </a:rPr>
-              <a:t>bash .../CST/tckgen_CST_L.sh</a:t>
-            </a:r>
-          </a:p>
-        </p:txBody>
-      </p:sp>
-      <p:sp>
-        <p:nvSpPr>
-          <p:cNvPr id="15" name="Rounded Rectangle 14"/>
+              <a:rPr sz="1200" i="1">
+                <a:solidFill>
+                  <a:srgbClr val="5A6B7B"/>
+                </a:solidFill>
+                <a:latin typeface="Yu Gothic"/>
+                <a:ea typeface="Yu Gothic"/>
+              </a:rPr>
+              <a:t>📝 まずは全脳のストリームラインをまとめて生成しておく。</a:t>
+            </a:r>
+          </a:p>
+        </p:txBody>
+      </p:sp>
+      <p:sp>
+        <p:nvSpPr>
+          <p:cNvPr id="16" name="Rounded Rectangle 15"/>
           <p:cNvSpPr/>
           <p:nvPr/>
         </p:nvSpPr>
@@ -11154,7 +12042,7 @@
       </p:sp>
       <p:sp>
         <p:nvSpPr>
-          <p:cNvPr id="16" name="TextBox 15"/>
+          <p:cNvPr id="17" name="TextBox 16"/>
           <p:cNvSpPr txBox="1"/>
           <p:nvPr/>
         </p:nvSpPr>
@@ -11200,7 +12088,7 @@
                 <a:latin typeface="Yu Gothic"/>
                 <a:ea typeface="Yu Gothic"/>
               </a:rPr>
-              <a:t>ターミナル実行のスクショ</a:t>
+              <a:t>text editor / コマンド記述のスクショ</a:t>
             </a:r>
           </a:p>
         </p:txBody>
@@ -11432,7 +12320,7 @@
                 <a:latin typeface="Yu Gothic"/>
                 <a:ea typeface="Yu Gothic"/>
               </a:rPr>
-              <a:t>STEP 6 ①</a:t>
+              <a:t>STEP 5</a:t>
             </a:r>
           </a:p>
         </p:txBody>
@@ -11468,7 +12356,7 @@
                 <a:latin typeface="Yu Gothic"/>
                 <a:ea typeface="Yu Gothic"/>
               </a:rPr>
-              <a:t>可視化：全ての神経</a:t>
+              <a:t>ROI で絞り込む（tckedit）</a:t>
             </a:r>
           </a:p>
         </p:txBody>
@@ -11547,7 +12435,7 @@
                 <a:latin typeface="Yu Gothic"/>
                 <a:ea typeface="Yu Gothic"/>
               </a:rPr>
-              <a:t>●  Tractography を選択</a:t>
+              <a:t>●  include で通過条件を指定</a:t>
             </a:r>
           </a:p>
           <a:p>
@@ -11567,7 +12455,7 @@
                 <a:latin typeface="Yu Gothic"/>
                 <a:ea typeface="Yu Gothic"/>
               </a:rPr>
-              <a:t>     mrview の Tool → Tractography を開く</a:t>
+              <a:t>     5つの ROI を全て通る神経だけを残す</a:t>
             </a:r>
           </a:p>
           <a:p>
@@ -11587,7 +12475,7 @@
                 <a:latin typeface="Yu Gothic"/>
                 <a:ea typeface="Yu Gothic"/>
               </a:rPr>
-              <a:t>●  Run で得た2ファイルを読み込む</a:t>
+              <a:t>●  入力</a:t>
             </a:r>
           </a:p>
           <a:p>
@@ -11607,7 +12495,7 @@
                 <a:latin typeface="Yu Gothic"/>
                 <a:ea typeface="Yu Gothic"/>
               </a:rPr>
-              <a:t>     生成したトラクトを表示</a:t>
+              <a:t>     tracks_10bil.tck（全脳トラクト）</a:t>
             </a:r>
           </a:p>
           <a:p>
@@ -11627,7 +12515,7 @@
                 <a:latin typeface="Yu Gothic"/>
                 <a:ea typeface="Yu Gothic"/>
               </a:rPr>
-              <a:t>●  結果</a:t>
+              <a:t>●  出力</a:t>
             </a:r>
           </a:p>
           <a:p>
@@ -11647,54 +12535,405 @@
                 <a:latin typeface="Yu Gothic"/>
                 <a:ea typeface="Yu Gothic"/>
               </a:rPr>
-              <a:t>     脳全体の神経線維（全トラクト）が見える図</a:t>
-            </a:r>
-          </a:p>
-        </p:txBody>
-      </p:sp>
-      <p:sp>
-        <p:nvSpPr>
-          <p:cNvPr id="10" name="TextBox 9"/>
-          <p:cNvSpPr txBox="1"/>
-          <p:nvPr/>
-        </p:nvSpPr>
-        <p:spPr>
-          <a:xfrm>
-            <a:off x="640080" y="5989320"/>
-            <a:ext cx="5212080" cy="640080"/>
-          </a:xfrm>
-          <a:prstGeom prst="rect">
-            <a:avLst/>
-          </a:prstGeom>
-          <a:noFill/>
-        </p:spPr>
-        <p:txBody>
-          <a:bodyPr wrap="square" anchor="t" lIns="25400" rIns="25400" tIns="25400" bIns="25400">
-            <a:spAutoFit/>
-          </a:bodyPr>
-          <a:lstStyle/>
+              <a:t>     tracks_CST.tck（CST のみ）</a:t>
+            </a:r>
+          </a:p>
           <a:p>
             <a:pPr algn="l">
               <a:lnSpc>
                 <a:spcPct val="115000"/>
               </a:lnSpc>
+              <a:spcAft>
+                <a:spcPts val="200"/>
+              </a:spcAft>
             </a:pPr>
             <a:r>
-              <a:rPr sz="1200" i="1">
-                <a:solidFill>
-                  <a:srgbClr val="5A6B7B"/>
-                </a:solidFill>
-                <a:latin typeface="Yu Gothic"/>
-                <a:ea typeface="Yu Gothic"/>
-              </a:rPr>
-              <a:t>📝 まずは絞り込み前の全神経を確認する。</a:t>
-            </a:r>
-          </a:p>
-        </p:txBody>
-      </p:sp>
-      <p:sp>
-        <p:nvSpPr>
-          <p:cNvPr id="11" name="Rounded Rectangle 10"/>
+              <a:rPr sz="1600" b="1">
+                <a:solidFill>
+                  <a:srgbClr val="1F6FB2"/>
+                </a:solidFill>
+                <a:latin typeface="Yu Gothic"/>
+                <a:ea typeface="Yu Gothic"/>
+              </a:rPr>
+              <a:t>●  実行</a:t>
+            </a:r>
+          </a:p>
+          <a:p>
+            <a:pPr algn="l">
+              <a:lnSpc>
+                <a:spcPct val="120000"/>
+              </a:lnSpc>
+              <a:spcAft>
+                <a:spcPts val="1200"/>
+              </a:spcAft>
+            </a:pPr>
+            <a:r>
+              <a:rPr sz="1400">
+                <a:solidFill>
+                  <a:srgbClr val="1B242E"/>
+                </a:solidFill>
+                <a:latin typeface="Yu Gothic"/>
+                <a:ea typeface="Yu Gothic"/>
+              </a:rPr>
+              <a:t>     bash でスクリプトを指定して走らせる</a:t>
+            </a:r>
+          </a:p>
+        </p:txBody>
+      </p:sp>
+      <p:sp>
+        <p:nvSpPr>
+          <p:cNvPr id="10" name="Rounded Rectangle 9"/>
+          <p:cNvSpPr/>
+          <p:nvPr/>
+        </p:nvSpPr>
+        <p:spPr>
+          <a:xfrm>
+            <a:off x="640080" y="3977639"/>
+            <a:ext cx="5212080" cy="2377440"/>
+          </a:xfrm>
+          <a:prstGeom prst="roundRect">
+            <a:avLst>
+              <a:gd name="adj" fmla="val 4000"/>
+            </a:avLst>
+          </a:prstGeom>
+          <a:solidFill>
+            <a:srgbClr val="1E2939"/>
+          </a:solidFill>
+          <a:ln>
+            <a:noFill/>
+          </a:ln>
+          <a:effectLst/>
+        </p:spPr>
+        <p:style>
+          <a:lnRef idx="1">
+            <a:schemeClr val="accent1"/>
+          </a:lnRef>
+          <a:fillRef idx="3">
+            <a:schemeClr val="accent1"/>
+          </a:fillRef>
+          <a:effectRef idx="2">
+            <a:schemeClr val="accent1"/>
+          </a:effectRef>
+          <a:fontRef idx="minor">
+            <a:schemeClr val="lt1"/>
+          </a:fontRef>
+        </p:style>
+        <p:txBody>
+          <a:bodyPr rtlCol="0" anchor="ctr"/>
+          <a:lstStyle/>
+          <a:p>
+            <a:pPr algn="ctr"/>
+          </a:p>
+        </p:txBody>
+      </p:sp>
+      <p:sp>
+        <p:nvSpPr>
+          <p:cNvPr id="11" name="Oval 10"/>
+          <p:cNvSpPr/>
+          <p:nvPr/>
+        </p:nvSpPr>
+        <p:spPr>
+          <a:xfrm>
+            <a:off x="804672" y="4123943"/>
+            <a:ext cx="109728" cy="109728"/>
+          </a:xfrm>
+          <a:prstGeom prst="ellipse">
+            <a:avLst/>
+          </a:prstGeom>
+          <a:solidFill>
+            <a:srgbClr val="FF5F57"/>
+          </a:solidFill>
+          <a:ln>
+            <a:noFill/>
+          </a:ln>
+          <a:effectLst/>
+        </p:spPr>
+        <p:style>
+          <a:lnRef idx="1">
+            <a:schemeClr val="accent1"/>
+          </a:lnRef>
+          <a:fillRef idx="3">
+            <a:schemeClr val="accent1"/>
+          </a:fillRef>
+          <a:effectRef idx="2">
+            <a:schemeClr val="accent1"/>
+          </a:effectRef>
+          <a:fontRef idx="minor">
+            <a:schemeClr val="lt1"/>
+          </a:fontRef>
+        </p:style>
+        <p:txBody>
+          <a:bodyPr rtlCol="0" anchor="ctr"/>
+          <a:lstStyle/>
+          <a:p>
+            <a:pPr algn="ctr"/>
+          </a:p>
+        </p:txBody>
+      </p:sp>
+      <p:sp>
+        <p:nvSpPr>
+          <p:cNvPr id="12" name="Oval 11"/>
+          <p:cNvSpPr/>
+          <p:nvPr/>
+        </p:nvSpPr>
+        <p:spPr>
+          <a:xfrm>
+            <a:off x="1005840" y="4123943"/>
+            <a:ext cx="109728" cy="109728"/>
+          </a:xfrm>
+          <a:prstGeom prst="ellipse">
+            <a:avLst/>
+          </a:prstGeom>
+          <a:solidFill>
+            <a:srgbClr val="FEBC2E"/>
+          </a:solidFill>
+          <a:ln>
+            <a:noFill/>
+          </a:ln>
+          <a:effectLst/>
+        </p:spPr>
+        <p:style>
+          <a:lnRef idx="1">
+            <a:schemeClr val="accent1"/>
+          </a:lnRef>
+          <a:fillRef idx="3">
+            <a:schemeClr val="accent1"/>
+          </a:fillRef>
+          <a:effectRef idx="2">
+            <a:schemeClr val="accent1"/>
+          </a:effectRef>
+          <a:fontRef idx="minor">
+            <a:schemeClr val="lt1"/>
+          </a:fontRef>
+        </p:style>
+        <p:txBody>
+          <a:bodyPr rtlCol="0" anchor="ctr"/>
+          <a:lstStyle/>
+          <a:p>
+            <a:pPr algn="ctr"/>
+          </a:p>
+        </p:txBody>
+      </p:sp>
+      <p:sp>
+        <p:nvSpPr>
+          <p:cNvPr id="13" name="Oval 12"/>
+          <p:cNvSpPr/>
+          <p:nvPr/>
+        </p:nvSpPr>
+        <p:spPr>
+          <a:xfrm>
+            <a:off x="1207008" y="4123943"/>
+            <a:ext cx="109728" cy="109728"/>
+          </a:xfrm>
+          <a:prstGeom prst="ellipse">
+            <a:avLst/>
+          </a:prstGeom>
+          <a:solidFill>
+            <a:srgbClr val="28C840"/>
+          </a:solidFill>
+          <a:ln>
+            <a:noFill/>
+          </a:ln>
+          <a:effectLst/>
+        </p:spPr>
+        <p:style>
+          <a:lnRef idx="1">
+            <a:schemeClr val="accent1"/>
+          </a:lnRef>
+          <a:fillRef idx="3">
+            <a:schemeClr val="accent1"/>
+          </a:fillRef>
+          <a:effectRef idx="2">
+            <a:schemeClr val="accent1"/>
+          </a:effectRef>
+          <a:fontRef idx="minor">
+            <a:schemeClr val="lt1"/>
+          </a:fontRef>
+        </p:style>
+        <p:txBody>
+          <a:bodyPr rtlCol="0" anchor="ctr"/>
+          <a:lstStyle/>
+          <a:p>
+            <a:pPr algn="ctr"/>
+          </a:p>
+        </p:txBody>
+      </p:sp>
+      <p:sp>
+        <p:nvSpPr>
+          <p:cNvPr id="14" name="TextBox 13"/>
+          <p:cNvSpPr txBox="1"/>
+          <p:nvPr/>
+        </p:nvSpPr>
+        <p:spPr>
+          <a:xfrm>
+            <a:off x="822960" y="4361687"/>
+            <a:ext cx="4846320" cy="1874520"/>
+          </a:xfrm>
+          <a:prstGeom prst="rect">
+            <a:avLst/>
+          </a:prstGeom>
+          <a:noFill/>
+        </p:spPr>
+        <p:txBody>
+          <a:bodyPr wrap="square">
+            <a:spAutoFit/>
+          </a:bodyPr>
+          <a:lstStyle/>
+          <a:p>
+            <a:pPr>
+              <a:lnSpc>
+                <a:spcPct val="110000"/>
+              </a:lnSpc>
+              <a:spcAft>
+                <a:spcPts val="300"/>
+              </a:spcAft>
+            </a:pPr>
+            <a:r>
+              <a:rPr sz="1300" b="1">
+                <a:solidFill>
+                  <a:srgbClr val="35C7EC"/>
+                </a:solidFill>
+                <a:latin typeface="Consolas"/>
+                <a:ea typeface="Consolas"/>
+              </a:rPr>
+              <a:t>$ </a:t>
+            </a:r>
+            <a:r>
+              <a:rPr sz="1300" b="0">
+                <a:solidFill>
+                  <a:srgbClr val="CBE6FF"/>
+                </a:solidFill>
+                <a:latin typeface="Consolas"/>
+                <a:ea typeface="Consolas"/>
+              </a:rPr>
+              <a:t>tckedit -include Medulla_L.mif -include Pons_L.mif \</a:t>
+            </a:r>
+          </a:p>
+          <a:p>
+            <a:pPr>
+              <a:lnSpc>
+                <a:spcPct val="110000"/>
+              </a:lnSpc>
+              <a:spcAft>
+                <a:spcPts val="300"/>
+              </a:spcAft>
+            </a:pPr>
+            <a:r>
+              <a:rPr sz="1300" b="1">
+                <a:solidFill>
+                  <a:srgbClr val="35C7EC"/>
+                </a:solidFill>
+                <a:latin typeface="Consolas"/>
+                <a:ea typeface="Consolas"/>
+              </a:rPr>
+              <a:t>$ </a:t>
+            </a:r>
+            <a:r>
+              <a:rPr sz="1300" b="0">
+                <a:solidFill>
+                  <a:srgbClr val="CBE6FF"/>
+                </a:solidFill>
+                <a:latin typeface="Consolas"/>
+                <a:ea typeface="Consolas"/>
+              </a:rPr>
+              <a:t>  -include Cerebral_peduncle_L.mif \</a:t>
+            </a:r>
+          </a:p>
+          <a:p>
+            <a:pPr>
+              <a:lnSpc>
+                <a:spcPct val="110000"/>
+              </a:lnSpc>
+              <a:spcAft>
+                <a:spcPts val="300"/>
+              </a:spcAft>
+            </a:pPr>
+            <a:r>
+              <a:rPr sz="1300" b="1">
+                <a:solidFill>
+                  <a:srgbClr val="35C7EC"/>
+                </a:solidFill>
+                <a:latin typeface="Consolas"/>
+                <a:ea typeface="Consolas"/>
+              </a:rPr>
+              <a:t>$ </a:t>
+            </a:r>
+            <a:r>
+              <a:rPr sz="1300" b="0">
+                <a:solidFill>
+                  <a:srgbClr val="CBE6FF"/>
+                </a:solidFill>
+                <a:latin typeface="Consolas"/>
+                <a:ea typeface="Consolas"/>
+              </a:rPr>
+              <a:t>  -include Internal_capsule_L.mif -include M1_hand_L.mif \</a:t>
+            </a:r>
+          </a:p>
+          <a:p>
+            <a:pPr>
+              <a:lnSpc>
+                <a:spcPct val="110000"/>
+              </a:lnSpc>
+              <a:spcAft>
+                <a:spcPts val="300"/>
+              </a:spcAft>
+            </a:pPr>
+            <a:r>
+              <a:rPr sz="1300" b="1">
+                <a:solidFill>
+                  <a:srgbClr val="35C7EC"/>
+                </a:solidFill>
+                <a:latin typeface="Consolas"/>
+                <a:ea typeface="Consolas"/>
+              </a:rPr>
+              <a:t>$ </a:t>
+            </a:r>
+            <a:r>
+              <a:rPr sz="1300" b="0">
+                <a:solidFill>
+                  <a:srgbClr val="CBE6FF"/>
+                </a:solidFill>
+                <a:latin typeface="Consolas"/>
+                <a:ea typeface="Consolas"/>
+              </a:rPr>
+              <a:t>  tracks_10bil.tck tracks_CST.tck</a:t>
+            </a:r>
+          </a:p>
+          <a:p>
+            <a:pPr>
+              <a:lnSpc>
+                <a:spcPct val="110000"/>
+              </a:lnSpc>
+              <a:spcAft>
+                <a:spcPts val="300"/>
+              </a:spcAft>
+            </a:pPr>
+            <a:r>
+              <a:rPr sz="1300" b="1">
+                <a:solidFill>
+                  <a:srgbClr val="35C7EC"/>
+                </a:solidFill>
+                <a:latin typeface="Consolas"/>
+                <a:ea typeface="Consolas"/>
+              </a:rPr>
+              <a:t>$ </a:t>
+            </a:r>
+            <a:r>
+              <a:rPr sz="1300" b="0">
+                <a:solidFill>
+                  <a:srgbClr val="CBE6FF"/>
+                </a:solidFill>
+                <a:latin typeface="Consolas"/>
+                <a:ea typeface="Consolas"/>
+              </a:rPr>
+              <a:t>bash .../CST/tckgen_CST_L.sh</a:t>
+            </a:r>
+          </a:p>
+        </p:txBody>
+      </p:sp>
+      <p:sp>
+        <p:nvSpPr>
+          <p:cNvPr id="15" name="Rounded Rectangle 14"/>
           <p:cNvSpPr/>
           <p:nvPr/>
         </p:nvSpPr>
@@ -11742,7 +12981,7 @@
       </p:sp>
       <p:sp>
         <p:nvSpPr>
-          <p:cNvPr id="12" name="TextBox 11"/>
+          <p:cNvPr id="16" name="TextBox 15"/>
           <p:cNvSpPr txBox="1"/>
           <p:nvPr/>
         </p:nvSpPr>
@@ -11788,7 +13027,7 @@
                 <a:latin typeface="Yu Gothic"/>
                 <a:ea typeface="Yu Gothic"/>
               </a:rPr>
-              <a:t>全トラクト表示のスクショ</a:t>
+              <a:t>ターミナル実行のスクショ</a:t>
             </a:r>
           </a:p>
         </p:txBody>

</xml_diff>